<commit_message>
feat: update presentation assets and add mobile screenshot recapture script
</commit_message>
<xml_diff>
--- a/docs/Task2-Presentation-bottomnav.pptx
+++ b/docs/Task2-Presentation-bottomnav.pptx
@@ -4,6 +4,9 @@
   <p:sldMasterIdLst>
     <p:sldMasterId id="2147483648" r:id="rId1"/>
   </p:sldMasterIdLst>
+  <p:notesMasterIdLst>
+    <p:notesMasterId r:id="rId50"/>
+  </p:notesMasterIdLst>
   <p:sldIdLst>
     <p:sldId id="256" r:id="rId2"/>
     <p:sldId id="257" r:id="rId3"/>
@@ -54,11 +57,8 @@
     <p:sldId id="302" r:id="rId48"/>
     <p:sldId id="303" r:id="rId49"/>
   </p:sldIdLst>
-  <p:notesMasterIdLst>
-    <p:notesMasterId r:id="rId50"/>
-  </p:notesMasterIdLst>
-  <p:sldSz cx="12191695" cy="6858000"/>
-  <p:notesSz cx="6858000" cy="12191695"/>
+  <p:sldSz cx="12192000" cy="6858000"/>
+  <p:notesSz cx="6858000" cy="12192000"/>
   <p:defaultTextStyle>
     <a:lvl1pPr marL="0" algn="l" defTabSz="914400" rtl="0" eaLnBrk="1" latinLnBrk="0" hangingPunct="1">
       <a:defRPr sz="1800" kern="1200">
@@ -151,7 +151,33 @@
       </a:defRPr>
     </a:lvl9pPr>
   </p:defaultTextStyle>
+  <p:extLst>
+    <p:ext uri="{EFAFB233-063F-42B5-8137-9DF3F51BA10A}">
+      <p15:sldGuideLst xmlns:p15="http://schemas.microsoft.com/office/powerpoint/2012/main"/>
+    </p:ext>
+  </p:extLst>
 </p:presentation>
+</file>
+
+<file path=ppt/changesInfos/changesInfo1.xml><?xml version="1.0" encoding="utf-8"?>
+<pc:chgInfo xmlns:a="http://schemas.openxmlformats.org/drawingml/2006/main" xmlns:r="http://schemas.openxmlformats.org/officeDocument/2006/relationships" xmlns:ac="http://schemas.microsoft.com/office/drawing/2013/main/command" xmlns:pc="http://schemas.microsoft.com/office/powerpoint/2013/main/command">
+  <pc:docChgLst>
+    <pc:chgData name="Alton Kholwani Muganda" userId="464338f6-1b06-4a73-a36d-8abbaea9bf60" providerId="ADAL" clId="{D9C534A9-2059-4910-9603-E05FB322D7F0}"/>
+    <pc:docChg chg="undo custSel addSld delSld">
+      <pc:chgData name="Alton Kholwani Muganda" userId="464338f6-1b06-4a73-a36d-8abbaea9bf60" providerId="ADAL" clId="{D9C534A9-2059-4910-9603-E05FB322D7F0}" dt="2026-10-05T19:09:18.912" v="1" actId="2696"/>
+      <pc:docMkLst>
+        <pc:docMk/>
+      </pc:docMkLst>
+      <pc:sldChg chg="add del">
+        <pc:chgData name="Alton Kholwani Muganda" userId="464338f6-1b06-4a73-a36d-8abbaea9bf60" providerId="ADAL" clId="{D9C534A9-2059-4910-9603-E05FB322D7F0}" dt="2026-10-05T19:09:18.912" v="1" actId="2696"/>
+        <pc:sldMkLst>
+          <pc:docMk/>
+          <pc:sldMk cId="0" sldId="256"/>
+        </pc:sldMkLst>
+      </pc:sldChg>
+    </pc:docChg>
+  </pc:docChgLst>
+</pc:chgInfo>
 </file>
 
 <file path=ppt/notesMasters/notesMaster1.xml><?xml version="1.0" encoding="utf-8"?>
@@ -176,234 +202,10 @@
           <a:chExt cx="0" cy="0"/>
         </a:xfrm>
       </p:grpSpPr>
-      <p:sp>
-        <p:nvSpPr>
-          <p:cNvPr id="2" name="Header Placeholder 1"/>
-          <p:cNvSpPr>
-            <a:spLocks noGrp="1"/>
-          </p:cNvSpPr>
-          <p:nvPr>
-            <p:ph type="hdr" sz="quarter"/>
-          </p:nvPr>
-        </p:nvSpPr>
-        <p:spPr>
-          <a:xfrm>
-            <a:off x="0" y="0"/>
-            <a:ext cx="2971800" cy="458788"/>
-          </a:xfrm>
-          <a:prstGeom prst="rect">
-            <a:avLst/>
-          </a:prstGeom>
-        </p:spPr>
-        <p:txBody>
-          <a:bodyPr vert="horz" lIns="91440" tIns="45720" rIns="91440" bIns="45720" rtlCol="0"/>
-          <a:lstStyle>
-            <a:lvl1pPr algn="l">
-              <a:defRPr sz="1200"/>
-            </a:lvl1pPr>
-          </a:lstStyle>
-          <a:p>
-            <a:endParaRPr lang="en-US"/>
-          </a:p>
-        </p:txBody>
-      </p:sp>
-      <p:sp>
-        <p:nvSpPr>
-          <p:cNvPr id="3" name="Date Placeholder 2"/>
-          <p:cNvSpPr>
-            <a:spLocks noGrp="1"/>
-          </p:cNvSpPr>
-          <p:nvPr>
-            <p:ph type="dt" idx="1"/>
-          </p:nvPr>
-        </p:nvSpPr>
-        <p:spPr>
-          <a:xfrm>
-            <a:off x="3884613" y="0"/>
-            <a:ext cx="2971800" cy="458788"/>
-          </a:xfrm>
-          <a:prstGeom prst="rect">
-            <a:avLst/>
-          </a:prstGeom>
-        </p:spPr>
-        <p:txBody>
-          <a:bodyPr vert="horz" lIns="91440" tIns="45720" rIns="91440" bIns="45720" rtlCol="0"/>
-          <a:lstStyle>
-            <a:lvl1pPr algn="r">
-              <a:defRPr sz="1200"/>
-            </a:lvl1pPr>
-          </a:lstStyle>
-          <a:p>
-            <a:fld id="{5282F153-3F37-0F45-9E97-73ACFA13230C}" type="datetimeFigureOut">
-              <a:rPr lang="en-US"/>
-              <a:t>7/23/19</a:t>
-            </a:fld>
-            <a:endParaRPr lang="en-US"/>
-          </a:p>
-        </p:txBody>
-      </p:sp>
-      <p:sp>
-        <p:nvSpPr>
-          <p:cNvPr id="4" name="Slide Image Placeholder 3"/>
-          <p:cNvSpPr>
-            <a:spLocks noGrp="1" noRot="1" noChangeAspect="1"/>
-          </p:cNvSpPr>
-          <p:nvPr>
-            <p:ph type="sldImg" idx="2"/>
-          </p:nvPr>
-        </p:nvSpPr>
-        <p:spPr>
-          <a:xfrm>
-            <a:off x="685800" y="1143000"/>
-            <a:ext cx="5486400" cy="3086100"/>
-          </a:xfrm>
-          <a:prstGeom prst="rect">
-            <a:avLst/>
-          </a:prstGeom>
-          <a:noFill/>
-          <a:ln w="12700">
-            <a:solidFill>
-              <a:prstClr val="black"/>
-            </a:solidFill>
-          </a:ln>
-        </p:spPr>
-        <p:txBody>
-          <a:bodyPr vert="horz" lIns="91440" tIns="45720" rIns="91440" bIns="45720" rtlCol="0" anchor="ctr"/>
-          <a:lstStyle/>
-          <a:p>
-            <a:endParaRPr lang="en-US"/>
-          </a:p>
-        </p:txBody>
-      </p:sp>
-      <p:sp>
-        <p:nvSpPr>
-          <p:cNvPr id="5" name="Notes Placeholder 4"/>
-          <p:cNvSpPr>
-            <a:spLocks noGrp="1"/>
-          </p:cNvSpPr>
-          <p:nvPr>
-            <p:ph type="body" sz="quarter" idx="3"/>
-          </p:nvPr>
-        </p:nvSpPr>
-        <p:spPr>
-          <a:xfrm>
-            <a:off x="685800" y="4400550"/>
-            <a:ext cx="5486400" cy="3600450"/>
-          </a:xfrm>
-          <a:prstGeom prst="rect">
-            <a:avLst/>
-          </a:prstGeom>
-        </p:spPr>
-        <p:txBody>
-          <a:bodyPr vert="horz" lIns="91440" tIns="45720" rIns="91440" bIns="45720" rtlCol="0"/>
-          <a:lstStyle/>
-          <a:p>
-            <a:pPr lvl="0"/>
-            <a:r>
-              <a:rPr lang="en-US"/>
-              <a:t>Click to edit Master text styles</a:t>
-            </a:r>
-          </a:p>
-          <a:p>
-            <a:pPr lvl="1"/>
-            <a:r>
-              <a:rPr lang="en-US"/>
-              <a:t>Second level</a:t>
-            </a:r>
-          </a:p>
-          <a:p>
-            <a:pPr lvl="2"/>
-            <a:r>
-              <a:rPr lang="en-US"/>
-              <a:t>Third level</a:t>
-            </a:r>
-          </a:p>
-          <a:p>
-            <a:pPr lvl="3"/>
-            <a:r>
-              <a:rPr lang="en-US"/>
-              <a:t>Fourth level</a:t>
-            </a:r>
-          </a:p>
-          <a:p>
-            <a:pPr lvl="4"/>
-            <a:r>
-              <a:rPr lang="en-US"/>
-              <a:t>Fifth level</a:t>
-            </a:r>
-          </a:p>
-        </p:txBody>
-      </p:sp>
-      <p:sp>
-        <p:nvSpPr>
-          <p:cNvPr id="6" name="Footer Placeholder 5"/>
-          <p:cNvSpPr>
-            <a:spLocks noGrp="1"/>
-          </p:cNvSpPr>
-          <p:nvPr>
-            <p:ph type="ftr" sz="quarter" idx="4"/>
-          </p:nvPr>
-        </p:nvSpPr>
-        <p:spPr>
-          <a:xfrm>
-            <a:off x="0" y="8685213"/>
-            <a:ext cx="2971800" cy="458787"/>
-          </a:xfrm>
-          <a:prstGeom prst="rect">
-            <a:avLst/>
-          </a:prstGeom>
-        </p:spPr>
-        <p:txBody>
-          <a:bodyPr vert="horz" lIns="91440" tIns="45720" rIns="91440" bIns="45720" rtlCol="0" anchor="b"/>
-          <a:lstStyle>
-            <a:lvl1pPr algn="l">
-              <a:defRPr sz="1200"/>
-            </a:lvl1pPr>
-          </a:lstStyle>
-          <a:p>
-            <a:endParaRPr lang="en-US"/>
-          </a:p>
-        </p:txBody>
-      </p:sp>
-      <p:sp>
-        <p:nvSpPr>
-          <p:cNvPr id="7" name="Slide Number Placeholder 6"/>
-          <p:cNvSpPr>
-            <a:spLocks noGrp="1"/>
-          </p:cNvSpPr>
-          <p:nvPr>
-            <p:ph type="sldNum" sz="quarter" idx="5"/>
-          </p:nvPr>
-        </p:nvSpPr>
-        <p:spPr>
-          <a:xfrm>
-            <a:off x="3884613" y="8685213"/>
-            <a:ext cx="2971800" cy="458787"/>
-          </a:xfrm>
-          <a:prstGeom prst="rect">
-            <a:avLst/>
-          </a:prstGeom>
-        </p:spPr>
-        <p:txBody>
-          <a:bodyPr vert="horz" lIns="91440" tIns="45720" rIns="91440" bIns="45720" rtlCol="0" anchor="b"/>
-          <a:lstStyle>
-            <a:lvl1pPr algn="r">
-              <a:defRPr sz="1200"/>
-            </a:lvl1pPr>
-          </a:lstStyle>
-          <a:p>
-            <a:fld id="{CE5E9CC1-C706-0F49-92D6-E571CC5EEA8F}" type="slidenum">
-              <a:rPr lang="en-US"/>
-              <a:t>‹#›</a:t>
-            </a:fld>
-            <a:endParaRPr lang="en-US"/>
-          </a:p>
-        </p:txBody>
-      </p:sp>
     </p:spTree>
     <p:extLst>
       <p:ext uri="{BB962C8B-B14F-4D97-AF65-F5344CB8AC3E}">
-        <p14:creationId xmlns:p14="http://schemas.microsoft.com/office/powerpoint/2010/main" val="1024086991"/>
+        <p14:creationId xmlns:p14="http://schemas.microsoft.com/office/powerpoint/2010/main" val="1224748380"/>
       </p:ext>
     </p:extLst>
   </p:cSld>
@@ -547,10 +349,6 @@
           <a:bodyPr/>
           <a:lstStyle/>
           <a:p>
-            <a:r>
-              <a:rPr lang="en-US" dirty="0"/>
-              <a:t/>
-            </a:r>
             <a:endParaRPr lang="en-US" dirty="0"/>
           </a:p>
         </p:txBody>
@@ -635,10 +433,6 @@
           <a:bodyPr/>
           <a:lstStyle/>
           <a:p>
-            <a:r>
-              <a:rPr lang="en-US" dirty="0"/>
-              <a:t/>
-            </a:r>
             <a:endParaRPr lang="en-US" dirty="0"/>
           </a:p>
         </p:txBody>
@@ -723,10 +517,6 @@
           <a:bodyPr/>
           <a:lstStyle/>
           <a:p>
-            <a:r>
-              <a:rPr lang="en-US" dirty="0"/>
-              <a:t/>
-            </a:r>
             <a:endParaRPr lang="en-US" dirty="0"/>
           </a:p>
         </p:txBody>
@@ -811,10 +601,6 @@
           <a:bodyPr/>
           <a:lstStyle/>
           <a:p>
-            <a:r>
-              <a:rPr lang="en-US" dirty="0"/>
-              <a:t/>
-            </a:r>
             <a:endParaRPr lang="en-US" dirty="0"/>
           </a:p>
         </p:txBody>
@@ -899,10 +685,6 @@
           <a:bodyPr/>
           <a:lstStyle/>
           <a:p>
-            <a:r>
-              <a:rPr lang="en-US" dirty="0"/>
-              <a:t/>
-            </a:r>
             <a:endParaRPr lang="en-US" dirty="0"/>
           </a:p>
         </p:txBody>
@@ -987,10 +769,6 @@
           <a:bodyPr/>
           <a:lstStyle/>
           <a:p>
-            <a:r>
-              <a:rPr lang="en-US" dirty="0"/>
-              <a:t/>
-            </a:r>
             <a:endParaRPr lang="en-US" dirty="0"/>
           </a:p>
         </p:txBody>
@@ -1075,10 +853,6 @@
           <a:bodyPr/>
           <a:lstStyle/>
           <a:p>
-            <a:r>
-              <a:rPr lang="en-US" dirty="0"/>
-              <a:t/>
-            </a:r>
             <a:endParaRPr lang="en-US" dirty="0"/>
           </a:p>
         </p:txBody>
@@ -1163,10 +937,6 @@
           <a:bodyPr/>
           <a:lstStyle/>
           <a:p>
-            <a:r>
-              <a:rPr lang="en-US" dirty="0"/>
-              <a:t/>
-            </a:r>
             <a:endParaRPr lang="en-US" dirty="0"/>
           </a:p>
         </p:txBody>
@@ -1251,10 +1021,6 @@
           <a:bodyPr/>
           <a:lstStyle/>
           <a:p>
-            <a:r>
-              <a:rPr lang="en-US" dirty="0"/>
-              <a:t/>
-            </a:r>
             <a:endParaRPr lang="en-US" dirty="0"/>
           </a:p>
         </p:txBody>
@@ -1339,10 +1105,6 @@
           <a:bodyPr/>
           <a:lstStyle/>
           <a:p>
-            <a:r>
-              <a:rPr lang="en-US" dirty="0"/>
-              <a:t/>
-            </a:r>
             <a:endParaRPr lang="en-US" dirty="0"/>
           </a:p>
         </p:txBody>
@@ -1427,10 +1189,6 @@
           <a:bodyPr/>
           <a:lstStyle/>
           <a:p>
-            <a:r>
-              <a:rPr lang="en-US" dirty="0"/>
-              <a:t/>
-            </a:r>
             <a:endParaRPr lang="en-US" dirty="0"/>
           </a:p>
         </p:txBody>
@@ -1515,10 +1273,6 @@
           <a:bodyPr/>
           <a:lstStyle/>
           <a:p>
-            <a:r>
-              <a:rPr lang="en-US" dirty="0"/>
-              <a:t/>
-            </a:r>
             <a:endParaRPr lang="en-US" dirty="0"/>
           </a:p>
         </p:txBody>
@@ -1603,10 +1357,6 @@
           <a:bodyPr/>
           <a:lstStyle/>
           <a:p>
-            <a:r>
-              <a:rPr lang="en-US" dirty="0"/>
-              <a:t/>
-            </a:r>
             <a:endParaRPr lang="en-US" dirty="0"/>
           </a:p>
         </p:txBody>
@@ -1691,10 +1441,6 @@
           <a:bodyPr/>
           <a:lstStyle/>
           <a:p>
-            <a:r>
-              <a:rPr lang="en-US" dirty="0"/>
-              <a:t/>
-            </a:r>
             <a:endParaRPr lang="en-US" dirty="0"/>
           </a:p>
         </p:txBody>
@@ -1779,10 +1525,6 @@
           <a:bodyPr/>
           <a:lstStyle/>
           <a:p>
-            <a:r>
-              <a:rPr lang="en-US" dirty="0"/>
-              <a:t/>
-            </a:r>
             <a:endParaRPr lang="en-US" dirty="0"/>
           </a:p>
         </p:txBody>
@@ -1867,10 +1609,6 @@
           <a:bodyPr/>
           <a:lstStyle/>
           <a:p>
-            <a:r>
-              <a:rPr lang="en-US" dirty="0"/>
-              <a:t/>
-            </a:r>
             <a:endParaRPr lang="en-US" dirty="0"/>
           </a:p>
         </p:txBody>
@@ -1955,10 +1693,6 @@
           <a:bodyPr/>
           <a:lstStyle/>
           <a:p>
-            <a:r>
-              <a:rPr lang="en-US" dirty="0"/>
-              <a:t/>
-            </a:r>
             <a:endParaRPr lang="en-US" dirty="0"/>
           </a:p>
         </p:txBody>
@@ -2043,10 +1777,6 @@
           <a:bodyPr/>
           <a:lstStyle/>
           <a:p>
-            <a:r>
-              <a:rPr lang="en-US" dirty="0"/>
-              <a:t/>
-            </a:r>
             <a:endParaRPr lang="en-US" dirty="0"/>
           </a:p>
         </p:txBody>
@@ -2131,10 +1861,6 @@
           <a:bodyPr/>
           <a:lstStyle/>
           <a:p>
-            <a:r>
-              <a:rPr lang="en-US" dirty="0"/>
-              <a:t/>
-            </a:r>
             <a:endParaRPr lang="en-US" dirty="0"/>
           </a:p>
         </p:txBody>
@@ -2219,10 +1945,6 @@
           <a:bodyPr/>
           <a:lstStyle/>
           <a:p>
-            <a:r>
-              <a:rPr lang="en-US" dirty="0"/>
-              <a:t/>
-            </a:r>
             <a:endParaRPr lang="en-US" dirty="0"/>
           </a:p>
         </p:txBody>
@@ -2307,10 +2029,6 @@
           <a:bodyPr/>
           <a:lstStyle/>
           <a:p>
-            <a:r>
-              <a:rPr lang="en-US" dirty="0"/>
-              <a:t/>
-            </a:r>
             <a:endParaRPr lang="en-US" dirty="0"/>
           </a:p>
         </p:txBody>
@@ -2395,10 +2113,6 @@
           <a:bodyPr/>
           <a:lstStyle/>
           <a:p>
-            <a:r>
-              <a:rPr lang="en-US" dirty="0"/>
-              <a:t/>
-            </a:r>
             <a:endParaRPr lang="en-US" dirty="0"/>
           </a:p>
         </p:txBody>
@@ -2483,10 +2197,6 @@
           <a:bodyPr/>
           <a:lstStyle/>
           <a:p>
-            <a:r>
-              <a:rPr lang="en-US" dirty="0"/>
-              <a:t/>
-            </a:r>
             <a:endParaRPr lang="en-US" dirty="0"/>
           </a:p>
         </p:txBody>
@@ -2571,10 +2281,6 @@
           <a:bodyPr/>
           <a:lstStyle/>
           <a:p>
-            <a:r>
-              <a:rPr lang="en-US" dirty="0"/>
-              <a:t/>
-            </a:r>
             <a:endParaRPr lang="en-US" dirty="0"/>
           </a:p>
         </p:txBody>
@@ -2659,10 +2365,6 @@
           <a:bodyPr/>
           <a:lstStyle/>
           <a:p>
-            <a:r>
-              <a:rPr lang="en-US" dirty="0"/>
-              <a:t/>
-            </a:r>
             <a:endParaRPr lang="en-US" dirty="0"/>
           </a:p>
         </p:txBody>
@@ -2747,10 +2449,6 @@
           <a:bodyPr/>
           <a:lstStyle/>
           <a:p>
-            <a:r>
-              <a:rPr lang="en-US" dirty="0"/>
-              <a:t/>
-            </a:r>
             <a:endParaRPr lang="en-US" dirty="0"/>
           </a:p>
         </p:txBody>
@@ -2835,10 +2533,6 @@
           <a:bodyPr/>
           <a:lstStyle/>
           <a:p>
-            <a:r>
-              <a:rPr lang="en-US" dirty="0"/>
-              <a:t/>
-            </a:r>
             <a:endParaRPr lang="en-US" dirty="0"/>
           </a:p>
         </p:txBody>
@@ -2923,10 +2617,6 @@
           <a:bodyPr/>
           <a:lstStyle/>
           <a:p>
-            <a:r>
-              <a:rPr lang="en-US" dirty="0"/>
-              <a:t/>
-            </a:r>
             <a:endParaRPr lang="en-US" dirty="0"/>
           </a:p>
         </p:txBody>
@@ -3011,10 +2701,6 @@
           <a:bodyPr/>
           <a:lstStyle/>
           <a:p>
-            <a:r>
-              <a:rPr lang="en-US" dirty="0"/>
-              <a:t/>
-            </a:r>
             <a:endParaRPr lang="en-US" dirty="0"/>
           </a:p>
         </p:txBody>
@@ -3099,10 +2785,6 @@
           <a:bodyPr/>
           <a:lstStyle/>
           <a:p>
-            <a:r>
-              <a:rPr lang="en-US" dirty="0"/>
-              <a:t/>
-            </a:r>
             <a:endParaRPr lang="en-US" dirty="0"/>
           </a:p>
         </p:txBody>
@@ -3187,10 +2869,6 @@
           <a:bodyPr/>
           <a:lstStyle/>
           <a:p>
-            <a:r>
-              <a:rPr lang="en-US" dirty="0"/>
-              <a:t/>
-            </a:r>
             <a:endParaRPr lang="en-US" dirty="0"/>
           </a:p>
         </p:txBody>
@@ -3275,10 +2953,6 @@
           <a:bodyPr/>
           <a:lstStyle/>
           <a:p>
-            <a:r>
-              <a:rPr lang="en-US" dirty="0"/>
-              <a:t/>
-            </a:r>
             <a:endParaRPr lang="en-US" dirty="0"/>
           </a:p>
         </p:txBody>
@@ -3363,10 +3037,6 @@
           <a:bodyPr/>
           <a:lstStyle/>
           <a:p>
-            <a:r>
-              <a:rPr lang="en-US" dirty="0"/>
-              <a:t/>
-            </a:r>
             <a:endParaRPr lang="en-US" dirty="0"/>
           </a:p>
         </p:txBody>
@@ -3451,10 +3121,6 @@
           <a:bodyPr/>
           <a:lstStyle/>
           <a:p>
-            <a:r>
-              <a:rPr lang="en-US" dirty="0"/>
-              <a:t/>
-            </a:r>
             <a:endParaRPr lang="en-US" dirty="0"/>
           </a:p>
         </p:txBody>
@@ -3539,10 +3205,6 @@
           <a:bodyPr/>
           <a:lstStyle/>
           <a:p>
-            <a:r>
-              <a:rPr lang="en-US" dirty="0"/>
-              <a:t/>
-            </a:r>
             <a:endParaRPr lang="en-US" dirty="0"/>
           </a:p>
         </p:txBody>
@@ -3627,10 +3289,6 @@
           <a:bodyPr/>
           <a:lstStyle/>
           <a:p>
-            <a:r>
-              <a:rPr lang="en-US" dirty="0"/>
-              <a:t/>
-            </a:r>
             <a:endParaRPr lang="en-US" dirty="0"/>
           </a:p>
         </p:txBody>
@@ -3715,10 +3373,6 @@
           <a:bodyPr/>
           <a:lstStyle/>
           <a:p>
-            <a:r>
-              <a:rPr lang="en-US" dirty="0"/>
-              <a:t/>
-            </a:r>
             <a:endParaRPr lang="en-US" dirty="0"/>
           </a:p>
         </p:txBody>
@@ -3803,10 +3457,6 @@
           <a:bodyPr/>
           <a:lstStyle/>
           <a:p>
-            <a:r>
-              <a:rPr lang="en-US" dirty="0"/>
-              <a:t/>
-            </a:r>
             <a:endParaRPr lang="en-US" dirty="0"/>
           </a:p>
         </p:txBody>
@@ -3891,10 +3541,6 @@
           <a:bodyPr/>
           <a:lstStyle/>
           <a:p>
-            <a:r>
-              <a:rPr lang="en-US" dirty="0"/>
-              <a:t/>
-            </a:r>
             <a:endParaRPr lang="en-US" dirty="0"/>
           </a:p>
         </p:txBody>
@@ -3979,10 +3625,6 @@
           <a:bodyPr/>
           <a:lstStyle/>
           <a:p>
-            <a:r>
-              <a:rPr lang="en-US" dirty="0"/>
-              <a:t/>
-            </a:r>
             <a:endParaRPr lang="en-US" dirty="0"/>
           </a:p>
         </p:txBody>
@@ -4067,10 +3709,6 @@
           <a:bodyPr/>
           <a:lstStyle/>
           <a:p>
-            <a:r>
-              <a:rPr lang="en-US" dirty="0"/>
-              <a:t/>
-            </a:r>
             <a:endParaRPr lang="en-US" dirty="0"/>
           </a:p>
         </p:txBody>
@@ -4155,10 +3793,6 @@
           <a:bodyPr/>
           <a:lstStyle/>
           <a:p>
-            <a:r>
-              <a:rPr lang="en-US" dirty="0"/>
-              <a:t/>
-            </a:r>
             <a:endParaRPr lang="en-US" dirty="0"/>
           </a:p>
         </p:txBody>
@@ -4243,10 +3877,6 @@
           <a:bodyPr/>
           <a:lstStyle/>
           <a:p>
-            <a:r>
-              <a:rPr lang="en-US" dirty="0"/>
-              <a:t/>
-            </a:r>
             <a:endParaRPr lang="en-US" dirty="0"/>
           </a:p>
         </p:txBody>
@@ -4331,10 +3961,6 @@
           <a:bodyPr/>
           <a:lstStyle/>
           <a:p>
-            <a:r>
-              <a:rPr lang="en-US" dirty="0"/>
-              <a:t/>
-            </a:r>
             <a:endParaRPr lang="en-US" dirty="0"/>
           </a:p>
         </p:txBody>
@@ -4419,10 +4045,6 @@
           <a:bodyPr/>
           <a:lstStyle/>
           <a:p>
-            <a:r>
-              <a:rPr lang="en-US" dirty="0"/>
-              <a:t/>
-            </a:r>
             <a:endParaRPr lang="en-US" dirty="0"/>
           </a:p>
         </p:txBody>
@@ -4507,10 +4129,6 @@
           <a:bodyPr/>
           <a:lstStyle/>
           <a:p>
-            <a:r>
-              <a:rPr lang="en-US" dirty="0"/>
-              <a:t/>
-            </a:r>
             <a:endParaRPr lang="en-US" dirty="0"/>
           </a:p>
         </p:txBody>
@@ -4595,10 +4213,6 @@
           <a:bodyPr/>
           <a:lstStyle/>
           <a:p>
-            <a:r>
-              <a:rPr lang="en-US" dirty="0"/>
-              <a:t/>
-            </a:r>
             <a:endParaRPr lang="en-US" dirty="0"/>
           </a:p>
         </p:txBody>
@@ -4683,10 +4297,6 @@
           <a:bodyPr/>
           <a:lstStyle/>
           <a:p>
-            <a:r>
-              <a:rPr lang="en-US" dirty="0"/>
-              <a:t/>
-            </a:r>
             <a:endParaRPr lang="en-US" dirty="0"/>
           </a:p>
         </p:txBody>
@@ -4760,6 +4370,11 @@
 <file path=ppt/slideMasters/slideMaster1.xml><?xml version="1.0" encoding="utf-8"?>
 <p:sldMaster xmlns:a="http://schemas.openxmlformats.org/drawingml/2006/main" xmlns:r="http://schemas.openxmlformats.org/officeDocument/2006/relationships" xmlns:p="http://schemas.openxmlformats.org/presentationml/2006/main">
   <p:cSld>
+    <p:bg>
+      <p:bgRef idx="1001">
+        <a:schemeClr val="bg1"/>
+      </p:bgRef>
+    </p:bg>
     <p:spTree>
       <p:nvGrpSpPr>
         <p:cNvPr id="1" name=""/>
@@ -5070,6 +4685,13 @@
           </a:solidFill>
           <a:ln/>
         </p:spPr>
+        <p:txBody>
+          <a:bodyPr/>
+          <a:lstStyle/>
+          <a:p>
+            <a:endParaRPr lang="en-US"/>
+          </a:p>
+        </p:txBody>
       </p:sp>
       <p:sp>
         <p:nvSpPr>
@@ -5092,7 +4714,7 @@
           <a:bodyPr wrap="square" rtlCol="0" anchor="ctr"/>
           <a:lstStyle/>
           <a:p>
-            <a:pPr indent="0" marL="0">
+            <a:pPr marL="0" indent="0">
               <a:buNone/>
             </a:pPr>
             <a:r>
@@ -5131,7 +4753,7 @@
           <a:bodyPr wrap="square" rtlCol="0" anchor="ctr"/>
           <a:lstStyle/>
           <a:p>
-            <a:pPr indent="0" marL="0">
+            <a:pPr marL="0" indent="0">
               <a:buNone/>
             </a:pPr>
             <a:r>
@@ -5193,6 +4815,13 @@
           </a:solidFill>
           <a:ln/>
         </p:spPr>
+        <p:txBody>
+          <a:bodyPr/>
+          <a:lstStyle/>
+          <a:p>
+            <a:endParaRPr lang="en-US"/>
+          </a:p>
+        </p:txBody>
       </p:sp>
       <p:sp>
         <p:nvSpPr>
@@ -5215,7 +4844,7 @@
           <a:bodyPr wrap="square" rtlCol="0" anchor="ctr"/>
           <a:lstStyle/>
           <a:p>
-            <a:pPr indent="0" marL="0">
+            <a:pPr marL="0" indent="0">
               <a:buNone/>
             </a:pPr>
             <a:r>
@@ -5235,15 +4864,15 @@
       </p:sp>
       <p:pic>
         <p:nvPicPr>
-          <p:cNvPr id="4" name="Image 0" descr="C:\Users\Kholwani\OneDrive - ADvTECH Ltd\BCAD 3\Sem 2\INSY7315\Part 2\emeris-pulse\docs\presentation-assets\06-member-phone-equipment.png">    </p:cNvPr>
+          <p:cNvPr id="4" name="Image 0" descr="C:\Users\Kholwani\OneDrive - ADvTECH Ltd\BCAD 3\Sem 2\INSY7315\Part 2\emeris-pulse\docs\presentation-assets\06-member-phone-equipment.png"/>
           <p:cNvPicPr>
             <a:picLocks noChangeAspect="1"/>
           </p:cNvPicPr>
           <p:nvPr/>
         </p:nvPicPr>
         <p:blipFill>
-          <a:blip r:embed="rId1"/>
-          <a:srcRect l="0" r="0" t="0" b="0"/>
+          <a:blip r:embed="rId3"/>
+          <a:srcRect/>
           <a:stretch/>
         </p:blipFill>
         <p:spPr>
@@ -5277,7 +4906,7 @@
           <a:bodyPr wrap="square" rtlCol="0" anchor="ctr"/>
           <a:lstStyle/>
           <a:p>
-            <a:pPr indent="0" marL="0">
+            <a:pPr marL="0" indent="0">
               <a:buNone/>
             </a:pPr>
             <a:r>
@@ -5339,6 +4968,13 @@
           </a:solidFill>
           <a:ln/>
         </p:spPr>
+        <p:txBody>
+          <a:bodyPr/>
+          <a:lstStyle/>
+          <a:p>
+            <a:endParaRPr lang="en-US"/>
+          </a:p>
+        </p:txBody>
       </p:sp>
       <p:sp>
         <p:nvSpPr>
@@ -5361,7 +4997,7 @@
           <a:bodyPr wrap="square" rtlCol="0" anchor="ctr"/>
           <a:lstStyle/>
           <a:p>
-            <a:pPr indent="0" marL="0">
+            <a:pPr marL="0" indent="0">
               <a:buNone/>
             </a:pPr>
             <a:r>
@@ -5381,15 +5017,15 @@
       </p:sp>
       <p:pic>
         <p:nvPicPr>
-          <p:cNvPr id="4" name="Image 0" descr="C:\Users\Kholwani\OneDrive - ADvTECH Ltd\BCAD 3\Sem 2\INSY7315\Part 2\emeris-pulse\docs\presentation-assets\07-member-phone-challenges.png">    </p:cNvPr>
+          <p:cNvPr id="4" name="Image 0" descr="C:\Users\Kholwani\OneDrive - ADvTECH Ltd\BCAD 3\Sem 2\INSY7315\Part 2\emeris-pulse\docs\presentation-assets\07-member-phone-challenges.png"/>
           <p:cNvPicPr>
             <a:picLocks noChangeAspect="1"/>
           </p:cNvPicPr>
           <p:nvPr/>
         </p:nvPicPr>
         <p:blipFill>
-          <a:blip r:embed="rId1"/>
-          <a:srcRect l="0" r="0" t="0" b="0"/>
+          <a:blip r:embed="rId3"/>
+          <a:srcRect/>
           <a:stretch/>
         </p:blipFill>
         <p:spPr>
@@ -5423,7 +5059,7 @@
           <a:bodyPr wrap="square" rtlCol="0" anchor="ctr"/>
           <a:lstStyle/>
           <a:p>
-            <a:pPr indent="0" marL="0">
+            <a:pPr marL="0" indent="0">
               <a:buNone/>
             </a:pPr>
             <a:r>
@@ -5485,6 +5121,13 @@
           </a:solidFill>
           <a:ln/>
         </p:spPr>
+        <p:txBody>
+          <a:bodyPr/>
+          <a:lstStyle/>
+          <a:p>
+            <a:endParaRPr lang="en-US"/>
+          </a:p>
+        </p:txBody>
       </p:sp>
       <p:sp>
         <p:nvSpPr>
@@ -5507,7 +5150,7 @@
           <a:bodyPr wrap="square" rtlCol="0" anchor="ctr"/>
           <a:lstStyle/>
           <a:p>
-            <a:pPr indent="0" marL="0">
+            <a:pPr marL="0" indent="0">
               <a:buNone/>
             </a:pPr>
             <a:r>
@@ -5527,15 +5170,15 @@
       </p:sp>
       <p:pic>
         <p:nvPicPr>
-          <p:cNvPr id="4" name="Image 0" descr="C:\Users\Kholwani\OneDrive - ADvTECH Ltd\BCAD 3\Sem 2\INSY7315\Part 2\emeris-pulse\docs\presentation-assets\08-member-phone-notifications.png">    </p:cNvPr>
+          <p:cNvPr id="4" name="Image 0" descr="C:\Users\Kholwani\OneDrive - ADvTECH Ltd\BCAD 3\Sem 2\INSY7315\Part 2\emeris-pulse\docs\presentation-assets\08-member-phone-notifications.png"/>
           <p:cNvPicPr>
             <a:picLocks noChangeAspect="1"/>
           </p:cNvPicPr>
           <p:nvPr/>
         </p:nvPicPr>
         <p:blipFill>
-          <a:blip r:embed="rId1"/>
-          <a:srcRect l="0" r="0" t="0" b="0"/>
+          <a:blip r:embed="rId3"/>
+          <a:srcRect/>
           <a:stretch/>
         </p:blipFill>
         <p:spPr>
@@ -5569,7 +5212,7 @@
           <a:bodyPr wrap="square" rtlCol="0" anchor="ctr"/>
           <a:lstStyle/>
           <a:p>
-            <a:pPr indent="0" marL="0">
+            <a:pPr marL="0" indent="0">
               <a:buNone/>
             </a:pPr>
             <a:r>
@@ -5631,6 +5274,13 @@
           </a:solidFill>
           <a:ln/>
         </p:spPr>
+        <p:txBody>
+          <a:bodyPr/>
+          <a:lstStyle/>
+          <a:p>
+            <a:endParaRPr lang="en-US"/>
+          </a:p>
+        </p:txBody>
       </p:sp>
       <p:sp>
         <p:nvSpPr>
@@ -5653,7 +5303,7 @@
           <a:bodyPr wrap="square" rtlCol="0" anchor="ctr"/>
           <a:lstStyle/>
           <a:p>
-            <a:pPr indent="0" marL="0">
+            <a:pPr marL="0" indent="0">
               <a:buNone/>
             </a:pPr>
             <a:r>
@@ -5673,15 +5323,15 @@
       </p:sp>
       <p:pic>
         <p:nvPicPr>
-          <p:cNvPr id="4" name="Image 0" descr="C:\Users\Kholwani\OneDrive - ADvTECH Ltd\BCAD 3\Sem 2\INSY7315\Part 2\emeris-pulse\docs\presentation-assets\09-member-phone-membership.png">    </p:cNvPr>
+          <p:cNvPr id="4" name="Image 0" descr="C:\Users\Kholwani\OneDrive - ADvTECH Ltd\BCAD 3\Sem 2\INSY7315\Part 2\emeris-pulse\docs\presentation-assets\09-member-phone-membership.png"/>
           <p:cNvPicPr>
             <a:picLocks noChangeAspect="1"/>
           </p:cNvPicPr>
           <p:nvPr/>
         </p:nvPicPr>
         <p:blipFill>
-          <a:blip r:embed="rId1"/>
-          <a:srcRect l="0" r="0" t="0" b="0"/>
+          <a:blip r:embed="rId3"/>
+          <a:srcRect/>
           <a:stretch/>
         </p:blipFill>
         <p:spPr>
@@ -5715,7 +5365,7 @@
           <a:bodyPr wrap="square" rtlCol="0" anchor="ctr"/>
           <a:lstStyle/>
           <a:p>
-            <a:pPr indent="0" marL="0">
+            <a:pPr marL="0" indent="0">
               <a:buNone/>
             </a:pPr>
             <a:r>
@@ -5777,6 +5427,13 @@
           </a:solidFill>
           <a:ln/>
         </p:spPr>
+        <p:txBody>
+          <a:bodyPr/>
+          <a:lstStyle/>
+          <a:p>
+            <a:endParaRPr lang="en-US"/>
+          </a:p>
+        </p:txBody>
       </p:sp>
       <p:sp>
         <p:nvSpPr>
@@ -5799,7 +5456,7 @@
           <a:bodyPr wrap="square" rtlCol="0" anchor="ctr"/>
           <a:lstStyle/>
           <a:p>
-            <a:pPr indent="0" marL="0">
+            <a:pPr marL="0" indent="0">
               <a:buNone/>
             </a:pPr>
             <a:r>
@@ -5819,15 +5476,15 @@
       </p:sp>
       <p:pic>
         <p:nvPicPr>
-          <p:cNvPr id="4" name="Image 0" descr="C:\Users\Kholwani\OneDrive - ADvTECH Ltd\BCAD 3\Sem 2\INSY7315\Part 2\emeris-pulse\docs\presentation-assets\10-member-phone-profile.png">    </p:cNvPr>
+          <p:cNvPr id="4" name="Image 0" descr="C:\Users\Kholwani\OneDrive - ADvTECH Ltd\BCAD 3\Sem 2\INSY7315\Part 2\emeris-pulse\docs\presentation-assets\10-member-phone-profile.png"/>
           <p:cNvPicPr>
             <a:picLocks noChangeAspect="1"/>
           </p:cNvPicPr>
           <p:nvPr/>
         </p:nvPicPr>
         <p:blipFill>
-          <a:blip r:embed="rId1"/>
-          <a:srcRect l="0" r="0" t="0" b="0"/>
+          <a:blip r:embed="rId3"/>
+          <a:srcRect/>
           <a:stretch/>
         </p:blipFill>
         <p:spPr>
@@ -5861,7 +5518,7 @@
           <a:bodyPr wrap="square" rtlCol="0" anchor="ctr"/>
           <a:lstStyle/>
           <a:p>
-            <a:pPr indent="0" marL="0">
+            <a:pPr marL="0" indent="0">
               <a:buNone/>
             </a:pPr>
             <a:r>
@@ -5923,6 +5580,13 @@
           </a:solidFill>
           <a:ln/>
         </p:spPr>
+        <p:txBody>
+          <a:bodyPr/>
+          <a:lstStyle/>
+          <a:p>
+            <a:endParaRPr lang="en-US"/>
+          </a:p>
+        </p:txBody>
       </p:sp>
       <p:sp>
         <p:nvSpPr>
@@ -5943,6 +5607,13 @@
           </a:solidFill>
           <a:ln/>
         </p:spPr>
+        <p:txBody>
+          <a:bodyPr/>
+          <a:lstStyle/>
+          <a:p>
+            <a:endParaRPr lang="en-US"/>
+          </a:p>
+        </p:txBody>
       </p:sp>
       <p:sp>
         <p:nvSpPr>
@@ -5965,7 +5636,7 @@
           <a:bodyPr wrap="square" rtlCol="0" anchor="ctr"/>
           <a:lstStyle/>
           <a:p>
-            <a:pPr indent="0" marL="0">
+            <a:pPr marL="0" indent="0">
               <a:buNone/>
             </a:pPr>
             <a:r>
@@ -6027,6 +5698,13 @@
           </a:solidFill>
           <a:ln/>
         </p:spPr>
+        <p:txBody>
+          <a:bodyPr/>
+          <a:lstStyle/>
+          <a:p>
+            <a:endParaRPr lang="en-US"/>
+          </a:p>
+        </p:txBody>
       </p:sp>
       <p:sp>
         <p:nvSpPr>
@@ -6049,7 +5727,7 @@
           <a:bodyPr wrap="square" rtlCol="0" anchor="ctr"/>
           <a:lstStyle/>
           <a:p>
-            <a:pPr indent="0" marL="0">
+            <a:pPr marL="0" indent="0">
               <a:buNone/>
             </a:pPr>
             <a:r>
@@ -6069,15 +5747,15 @@
       </p:sp>
       <p:pic>
         <p:nvPicPr>
-          <p:cNvPr id="4" name="Image 0" descr="C:\Users\Kholwani\OneDrive - ADvTECH Ltd\BCAD 3\Sem 2\INSY7315\Part 2\emeris-pulse\docs\presentation-assets\14-member-pending-membership.png">    </p:cNvPr>
+          <p:cNvPr id="4" name="Image 0" descr="C:\Users\Kholwani\OneDrive - ADvTECH Ltd\BCAD 3\Sem 2\INSY7315\Part 2\emeris-pulse\docs\presentation-assets\14-member-pending-membership.png"/>
           <p:cNvPicPr>
             <a:picLocks noChangeAspect="1"/>
           </p:cNvPicPr>
           <p:nvPr/>
         </p:nvPicPr>
         <p:blipFill>
-          <a:blip r:embed="rId1"/>
-          <a:srcRect l="0" r="0" t="0" b="0"/>
+          <a:blip r:embed="rId3"/>
+          <a:srcRect/>
           <a:stretch/>
         </p:blipFill>
         <p:spPr>
@@ -6111,7 +5789,7 @@
           <a:bodyPr wrap="square" rtlCol="0" anchor="ctr"/>
           <a:lstStyle/>
           <a:p>
-            <a:pPr indent="0" marL="0">
+            <a:pPr marL="0" indent="0">
               <a:buNone/>
             </a:pPr>
             <a:r>
@@ -6173,6 +5851,13 @@
           </a:solidFill>
           <a:ln/>
         </p:spPr>
+        <p:txBody>
+          <a:bodyPr/>
+          <a:lstStyle/>
+          <a:p>
+            <a:endParaRPr lang="en-US"/>
+          </a:p>
+        </p:txBody>
       </p:sp>
       <p:sp>
         <p:nvSpPr>
@@ -6195,7 +5880,7 @@
           <a:bodyPr wrap="square" rtlCol="0" anchor="ctr"/>
           <a:lstStyle/>
           <a:p>
-            <a:pPr indent="0" marL="0">
+            <a:pPr marL="0" indent="0">
               <a:buNone/>
             </a:pPr>
             <a:r>
@@ -6215,15 +5900,15 @@
       </p:sp>
       <p:pic>
         <p:nvPicPr>
-          <p:cNvPr id="4" name="Image 0" descr="C:\Users\Kholwani\OneDrive - ADvTECH Ltd\BCAD 3\Sem 2\INSY7315\Part 2\emeris-pulse\docs\presentation-assets\15-member-pending-access.png">    </p:cNvPr>
+          <p:cNvPr id="4" name="Image 0" descr="C:\Users\Kholwani\OneDrive - ADvTECH Ltd\BCAD 3\Sem 2\INSY7315\Part 2\emeris-pulse\docs\presentation-assets\15-member-pending-access.png"/>
           <p:cNvPicPr>
             <a:picLocks noChangeAspect="1"/>
           </p:cNvPicPr>
           <p:nvPr/>
         </p:nvPicPr>
         <p:blipFill>
-          <a:blip r:embed="rId1"/>
-          <a:srcRect l="0" r="0" t="0" b="0"/>
+          <a:blip r:embed="rId3"/>
+          <a:srcRect/>
           <a:stretch/>
         </p:blipFill>
         <p:spPr>
@@ -6257,7 +5942,7 @@
           <a:bodyPr wrap="square" rtlCol="0" anchor="ctr"/>
           <a:lstStyle/>
           <a:p>
-            <a:pPr indent="0" marL="0">
+            <a:pPr marL="0" indent="0">
               <a:buNone/>
             </a:pPr>
             <a:r>
@@ -6319,6 +6004,13 @@
           </a:solidFill>
           <a:ln/>
         </p:spPr>
+        <p:txBody>
+          <a:bodyPr/>
+          <a:lstStyle/>
+          <a:p>
+            <a:endParaRPr lang="en-US"/>
+          </a:p>
+        </p:txBody>
       </p:sp>
       <p:sp>
         <p:nvSpPr>
@@ -6341,7 +6033,7 @@
           <a:bodyPr wrap="square" rtlCol="0" anchor="ctr"/>
           <a:lstStyle/>
           <a:p>
-            <a:pPr indent="0" marL="0">
+            <a:pPr marL="0" indent="0">
               <a:buNone/>
             </a:pPr>
             <a:r>
@@ -6361,15 +6053,15 @@
       </p:sp>
       <p:pic>
         <p:nvPicPr>
-          <p:cNvPr id="4" name="Image 0" descr="C:\Users\Kholwani\OneDrive - ADvTECH Ltd\BCAD 3\Sem 2\INSY7315\Part 2\emeris-pulse\docs\presentation-assets\16-member-frozen-membership.png">    </p:cNvPr>
+          <p:cNvPr id="4" name="Image 0" descr="C:\Users\Kholwani\OneDrive - ADvTECH Ltd\BCAD 3\Sem 2\INSY7315\Part 2\emeris-pulse\docs\presentation-assets\16-member-frozen-membership.png"/>
           <p:cNvPicPr>
             <a:picLocks noChangeAspect="1"/>
           </p:cNvPicPr>
           <p:nvPr/>
         </p:nvPicPr>
         <p:blipFill>
-          <a:blip r:embed="rId1"/>
-          <a:srcRect l="0" r="0" t="0" b="0"/>
+          <a:blip r:embed="rId3"/>
+          <a:srcRect/>
           <a:stretch/>
         </p:blipFill>
         <p:spPr>
@@ -6403,7 +6095,7 @@
           <a:bodyPr wrap="square" rtlCol="0" anchor="ctr"/>
           <a:lstStyle/>
           <a:p>
-            <a:pPr indent="0" marL="0">
+            <a:pPr marL="0" indent="0">
               <a:buNone/>
             </a:pPr>
             <a:r>
@@ -6465,6 +6157,13 @@
           </a:solidFill>
           <a:ln/>
         </p:spPr>
+        <p:txBody>
+          <a:bodyPr/>
+          <a:lstStyle/>
+          <a:p>
+            <a:endParaRPr lang="en-US"/>
+          </a:p>
+        </p:txBody>
       </p:sp>
       <p:sp>
         <p:nvSpPr>
@@ -6485,6 +6184,13 @@
           </a:solidFill>
           <a:ln/>
         </p:spPr>
+        <p:txBody>
+          <a:bodyPr/>
+          <a:lstStyle/>
+          <a:p>
+            <a:endParaRPr lang="en-US"/>
+          </a:p>
+        </p:txBody>
       </p:sp>
       <p:sp>
         <p:nvSpPr>
@@ -6507,7 +6213,7 @@
           <a:bodyPr wrap="square" rtlCol="0" anchor="ctr"/>
           <a:lstStyle/>
           <a:p>
-            <a:pPr indent="0" marL="0">
+            <a:pPr marL="0" indent="0">
               <a:buNone/>
             </a:pPr>
             <a:r>
@@ -6569,6 +6275,13 @@
           </a:solidFill>
           <a:ln/>
         </p:spPr>
+        <p:txBody>
+          <a:bodyPr/>
+          <a:lstStyle/>
+          <a:p>
+            <a:endParaRPr lang="en-US"/>
+          </a:p>
+        </p:txBody>
       </p:sp>
       <p:sp>
         <p:nvSpPr>
@@ -6591,7 +6304,7 @@
           <a:bodyPr wrap="square" rtlCol="0" anchor="ctr"/>
           <a:lstStyle/>
           <a:p>
-            <a:pPr indent="0" marL="0">
+            <a:pPr marL="0" indent="0">
               <a:buNone/>
             </a:pPr>
             <a:r>
@@ -6747,6 +6460,13 @@
           </a:solidFill>
           <a:ln/>
         </p:spPr>
+        <p:txBody>
+          <a:bodyPr/>
+          <a:lstStyle/>
+          <a:p>
+            <a:endParaRPr lang="en-US"/>
+          </a:p>
+        </p:txBody>
       </p:sp>
       <p:sp>
         <p:nvSpPr>
@@ -6769,7 +6489,7 @@
           <a:bodyPr wrap="square" rtlCol="0" anchor="ctr"/>
           <a:lstStyle/>
           <a:p>
-            <a:pPr indent="0" marL="0">
+            <a:pPr marL="0" indent="0">
               <a:buNone/>
             </a:pPr>
             <a:r>
@@ -6789,15 +6509,15 @@
       </p:sp>
       <p:pic>
         <p:nvPicPr>
-          <p:cNvPr id="4" name="Image 0" descr="C:\Users\Kholwani\OneDrive - ADvTECH Ltd\BCAD 3\Sem 2\INSY7315\Part 2\emeris-pulse\docs\presentation-assets\17-instructor-today.png">    </p:cNvPr>
+          <p:cNvPr id="4" name="Image 0" descr="C:\Users\Kholwani\OneDrive - ADvTECH Ltd\BCAD 3\Sem 2\INSY7315\Part 2\emeris-pulse\docs\presentation-assets\17-instructor-today.png"/>
           <p:cNvPicPr>
             <a:picLocks noChangeAspect="1"/>
           </p:cNvPicPr>
           <p:nvPr/>
         </p:nvPicPr>
         <p:blipFill>
-          <a:blip r:embed="rId1"/>
-          <a:srcRect l="0" r="0" t="0" b="0"/>
+          <a:blip r:embed="rId3"/>
+          <a:srcRect/>
           <a:stretch/>
         </p:blipFill>
         <p:spPr>
@@ -6831,7 +6551,7 @@
           <a:bodyPr wrap="square" rtlCol="0" anchor="ctr"/>
           <a:lstStyle/>
           <a:p>
-            <a:pPr indent="0" marL="0">
+            <a:pPr marL="0" indent="0">
               <a:buNone/>
             </a:pPr>
             <a:r>
@@ -6893,6 +6613,13 @@
           </a:solidFill>
           <a:ln/>
         </p:spPr>
+        <p:txBody>
+          <a:bodyPr/>
+          <a:lstStyle/>
+          <a:p>
+            <a:endParaRPr lang="en-US"/>
+          </a:p>
+        </p:txBody>
       </p:sp>
       <p:sp>
         <p:nvSpPr>
@@ -6915,7 +6642,7 @@
           <a:bodyPr wrap="square" rtlCol="0" anchor="ctr"/>
           <a:lstStyle/>
           <a:p>
-            <a:pPr indent="0" marL="0">
+            <a:pPr marL="0" indent="0">
               <a:buNone/>
             </a:pPr>
             <a:r>
@@ -6935,15 +6662,15 @@
       </p:sp>
       <p:pic>
         <p:nvPicPr>
-          <p:cNvPr id="4" name="Image 0" descr="C:\Users\Kholwani\OneDrive - ADvTECH Ltd\BCAD 3\Sem 2\INSY7315\Part 2\emeris-pulse\docs\presentation-assets\18-instructor-class-roster.png">    </p:cNvPr>
+          <p:cNvPr id="4" name="Image 0" descr="C:\Users\Kholwani\OneDrive - ADvTECH Ltd\BCAD 3\Sem 2\INSY7315\Part 2\emeris-pulse\docs\presentation-assets\18-instructor-class-roster.png"/>
           <p:cNvPicPr>
             <a:picLocks noChangeAspect="1"/>
           </p:cNvPicPr>
           <p:nvPr/>
         </p:nvPicPr>
         <p:blipFill>
-          <a:blip r:embed="rId1"/>
-          <a:srcRect l="0" r="0" t="0" b="0"/>
+          <a:blip r:embed="rId3"/>
+          <a:srcRect/>
           <a:stretch/>
         </p:blipFill>
         <p:spPr>
@@ -6977,7 +6704,7 @@
           <a:bodyPr wrap="square" rtlCol="0" anchor="ctr"/>
           <a:lstStyle/>
           <a:p>
-            <a:pPr indent="0" marL="0">
+            <a:pPr marL="0" indent="0">
               <a:buNone/>
             </a:pPr>
             <a:r>
@@ -7039,6 +6766,13 @@
           </a:solidFill>
           <a:ln/>
         </p:spPr>
+        <p:txBody>
+          <a:bodyPr/>
+          <a:lstStyle/>
+          <a:p>
+            <a:endParaRPr lang="en-US"/>
+          </a:p>
+        </p:txBody>
       </p:sp>
       <p:sp>
         <p:nvSpPr>
@@ -7061,7 +6795,7 @@
           <a:bodyPr wrap="square" rtlCol="0" anchor="ctr"/>
           <a:lstStyle/>
           <a:p>
-            <a:pPr indent="0" marL="0">
+            <a:pPr marL="0" indent="0">
               <a:buNone/>
             </a:pPr>
             <a:r>
@@ -7081,15 +6815,15 @@
       </p:sp>
       <p:pic>
         <p:nvPicPr>
-          <p:cNvPr id="4" name="Image 0" descr="C:\Users\Kholwani\OneDrive - ADvTECH Ltd\BCAD 3\Sem 2\INSY7315\Part 2\emeris-pulse\docs\presentation-assets\19-instructor-attendance.png">    </p:cNvPr>
+          <p:cNvPr id="4" name="Image 0" descr="C:\Users\Kholwani\OneDrive - ADvTECH Ltd\BCAD 3\Sem 2\INSY7315\Part 2\emeris-pulse\docs\presentation-assets\19-instructor-attendance.png"/>
           <p:cNvPicPr>
             <a:picLocks noChangeAspect="1"/>
           </p:cNvPicPr>
           <p:nvPr/>
         </p:nvPicPr>
         <p:blipFill>
-          <a:blip r:embed="rId1"/>
-          <a:srcRect l="0" r="0" t="0" b="0"/>
+          <a:blip r:embed="rId3"/>
+          <a:srcRect/>
           <a:stretch/>
         </p:blipFill>
         <p:spPr>
@@ -7123,7 +6857,7 @@
           <a:bodyPr wrap="square" rtlCol="0" anchor="ctr"/>
           <a:lstStyle/>
           <a:p>
-            <a:pPr indent="0" marL="0">
+            <a:pPr marL="0" indent="0">
               <a:buNone/>
             </a:pPr>
             <a:r>
@@ -7185,6 +6919,13 @@
           </a:solidFill>
           <a:ln/>
         </p:spPr>
+        <p:txBody>
+          <a:bodyPr/>
+          <a:lstStyle/>
+          <a:p>
+            <a:endParaRPr lang="en-US"/>
+          </a:p>
+        </p:txBody>
       </p:sp>
       <p:sp>
         <p:nvSpPr>
@@ -7207,7 +6948,7 @@
           <a:bodyPr wrap="square" rtlCol="0" anchor="ctr"/>
           <a:lstStyle/>
           <a:p>
-            <a:pPr indent="0" marL="0">
+            <a:pPr marL="0" indent="0">
               <a:buNone/>
             </a:pPr>
             <a:r>
@@ -7227,15 +6968,15 @@
       </p:sp>
       <p:pic>
         <p:nvPicPr>
-          <p:cNvPr id="4" name="Image 0" descr="C:\Users\Kholwani\OneDrive - ADvTECH Ltd\BCAD 3\Sem 2\INSY7315\Part 2\emeris-pulse\docs\presentation-assets\19b-instructor-message.png">    </p:cNvPr>
+          <p:cNvPr id="4" name="Image 0" descr="C:\Users\Kholwani\OneDrive - ADvTECH Ltd\BCAD 3\Sem 2\INSY7315\Part 2\emeris-pulse\docs\presentation-assets\19b-instructor-message.png"/>
           <p:cNvPicPr>
             <a:picLocks noChangeAspect="1"/>
           </p:cNvPicPr>
           <p:nvPr/>
         </p:nvPicPr>
         <p:blipFill>
-          <a:blip r:embed="rId1"/>
-          <a:srcRect l="0" r="0" t="0" b="0"/>
+          <a:blip r:embed="rId3"/>
+          <a:srcRect/>
           <a:stretch/>
         </p:blipFill>
         <p:spPr>
@@ -7269,7 +7010,7 @@
           <a:bodyPr wrap="square" rtlCol="0" anchor="ctr"/>
           <a:lstStyle/>
           <a:p>
-            <a:pPr indent="0" marL="0">
+            <a:pPr marL="0" indent="0">
               <a:buNone/>
             </a:pPr>
             <a:r>
@@ -7331,6 +7072,13 @@
           </a:solidFill>
           <a:ln/>
         </p:spPr>
+        <p:txBody>
+          <a:bodyPr/>
+          <a:lstStyle/>
+          <a:p>
+            <a:endParaRPr lang="en-US"/>
+          </a:p>
+        </p:txBody>
       </p:sp>
       <p:sp>
         <p:nvSpPr>
@@ -7353,7 +7101,7 @@
           <a:bodyPr wrap="square" rtlCol="0" anchor="ctr"/>
           <a:lstStyle/>
           <a:p>
-            <a:pPr indent="0" marL="0">
+            <a:pPr marL="0" indent="0">
               <a:buNone/>
             </a:pPr>
             <a:r>
@@ -7373,15 +7121,15 @@
       </p:sp>
       <p:pic>
         <p:nvPicPr>
-          <p:cNvPr id="4" name="Image 0" descr="C:\Users\Kholwani\OneDrive - ADvTECH Ltd\BCAD 3\Sem 2\INSY7315\Part 2\emeris-pulse\docs\presentation-assets\20-instructor-studio.png">    </p:cNvPr>
+          <p:cNvPr id="4" name="Image 0" descr="C:\Users\Kholwani\OneDrive - ADvTECH Ltd\BCAD 3\Sem 2\INSY7315\Part 2\emeris-pulse\docs\presentation-assets\20-instructor-studio.png"/>
           <p:cNvPicPr>
             <a:picLocks noChangeAspect="1"/>
           </p:cNvPicPr>
           <p:nvPr/>
         </p:nvPicPr>
         <p:blipFill>
-          <a:blip r:embed="rId1"/>
-          <a:srcRect l="0" r="0" t="0" b="0"/>
+          <a:blip r:embed="rId3"/>
+          <a:srcRect/>
           <a:stretch/>
         </p:blipFill>
         <p:spPr>
@@ -7415,7 +7163,7 @@
           <a:bodyPr wrap="square" rtlCol="0" anchor="ctr"/>
           <a:lstStyle/>
           <a:p>
-            <a:pPr indent="0" marL="0">
+            <a:pPr marL="0" indent="0">
               <a:buNone/>
             </a:pPr>
             <a:r>
@@ -7477,6 +7225,13 @@
           </a:solidFill>
           <a:ln/>
         </p:spPr>
+        <p:txBody>
+          <a:bodyPr/>
+          <a:lstStyle/>
+          <a:p>
+            <a:endParaRPr lang="en-US"/>
+          </a:p>
+        </p:txBody>
       </p:sp>
       <p:sp>
         <p:nvSpPr>
@@ -7497,6 +7252,13 @@
           </a:solidFill>
           <a:ln/>
         </p:spPr>
+        <p:txBody>
+          <a:bodyPr/>
+          <a:lstStyle/>
+          <a:p>
+            <a:endParaRPr lang="en-US"/>
+          </a:p>
+        </p:txBody>
       </p:sp>
       <p:sp>
         <p:nvSpPr>
@@ -7519,7 +7281,7 @@
           <a:bodyPr wrap="square" rtlCol="0" anchor="ctr"/>
           <a:lstStyle/>
           <a:p>
-            <a:pPr indent="0" marL="0">
+            <a:pPr marL="0" indent="0">
               <a:buNone/>
             </a:pPr>
             <a:r>
@@ -7581,6 +7343,13 @@
           </a:solidFill>
           <a:ln/>
         </p:spPr>
+        <p:txBody>
+          <a:bodyPr/>
+          <a:lstStyle/>
+          <a:p>
+            <a:endParaRPr lang="en-US"/>
+          </a:p>
+        </p:txBody>
       </p:sp>
       <p:sp>
         <p:nvSpPr>
@@ -7603,7 +7372,7 @@
           <a:bodyPr wrap="square" rtlCol="0" anchor="ctr"/>
           <a:lstStyle/>
           <a:p>
-            <a:pPr indent="0" marL="0">
+            <a:pPr marL="0" indent="0">
               <a:buNone/>
             </a:pPr>
             <a:r>
@@ -7623,15 +7392,15 @@
       </p:sp>
       <p:pic>
         <p:nvPicPr>
-          <p:cNvPr id="4" name="Image 0" descr="C:\Users\Kholwani\OneDrive - ADvTECH Ltd\BCAD 3\Sem 2\INSY7315\Part 2\emeris-pulse\docs\presentation-assets\21b-scan-pair-member-qr-fresh.png">    </p:cNvPr>
+          <p:cNvPr id="4" name="Image 0" descr="C:\Users\Kholwani\OneDrive - ADvTECH Ltd\BCAD 3\Sem 2\INSY7315\Part 2\emeris-pulse\docs\presentation-assets\21b-scan-pair-member-qr-fresh.png"/>
           <p:cNvPicPr>
             <a:picLocks noChangeAspect="1"/>
           </p:cNvPicPr>
           <p:nvPr/>
         </p:nvPicPr>
         <p:blipFill>
-          <a:blip r:embed="rId1"/>
-          <a:srcRect l="0" r="0" t="0" b="0"/>
+          <a:blip r:embed="rId3"/>
+          <a:srcRect/>
           <a:stretch/>
         </p:blipFill>
         <p:spPr>
@@ -7665,7 +7434,7 @@
           <a:bodyPr wrap="square" rtlCol="0" anchor="ctr"/>
           <a:lstStyle/>
           <a:p>
-            <a:pPr indent="0" marL="0">
+            <a:pPr marL="0" indent="0">
               <a:buNone/>
             </a:pPr>
             <a:r>
@@ -7727,6 +7496,13 @@
           </a:solidFill>
           <a:ln/>
         </p:spPr>
+        <p:txBody>
+          <a:bodyPr/>
+          <a:lstStyle/>
+          <a:p>
+            <a:endParaRPr lang="en-US"/>
+          </a:p>
+        </p:txBody>
       </p:sp>
       <p:sp>
         <p:nvSpPr>
@@ -7749,7 +7525,7 @@
           <a:bodyPr wrap="square" rtlCol="0" anchor="ctr"/>
           <a:lstStyle/>
           <a:p>
-            <a:pPr indent="0" marL="0">
+            <a:pPr marL="0" indent="0">
               <a:buNone/>
             </a:pPr>
             <a:r>
@@ -7769,15 +7545,15 @@
       </p:sp>
       <p:pic>
         <p:nvPicPr>
-          <p:cNvPr id="4" name="Image 0" descr="C:\Users\Kholwani\OneDrive - ADvTECH Ltd\BCAD 3\Sem 2\INSY7315\Part 2\emeris-pulse\docs\presentation-assets\23-admin-scan-entry.png">    </p:cNvPr>
+          <p:cNvPr id="4" name="Image 0" descr="C:\Users\Kholwani\OneDrive - ADvTECH Ltd\BCAD 3\Sem 2\INSY7315\Part 2\emeris-pulse\docs\presentation-assets\23-admin-scan-entry.png"/>
           <p:cNvPicPr>
             <a:picLocks noChangeAspect="1"/>
           </p:cNvPicPr>
           <p:nvPr/>
         </p:nvPicPr>
         <p:blipFill>
-          <a:blip r:embed="rId1"/>
-          <a:srcRect l="0" r="0" t="0" b="0"/>
+          <a:blip r:embed="rId3"/>
+          <a:srcRect/>
           <a:stretch/>
         </p:blipFill>
         <p:spPr>
@@ -7811,7 +7587,7 @@
           <a:bodyPr wrap="square" rtlCol="0" anchor="ctr"/>
           <a:lstStyle/>
           <a:p>
-            <a:pPr indent="0" marL="0">
+            <a:pPr marL="0" indent="0">
               <a:buNone/>
             </a:pPr>
             <a:r>
@@ -7873,6 +7649,13 @@
           </a:solidFill>
           <a:ln/>
         </p:spPr>
+        <p:txBody>
+          <a:bodyPr/>
+          <a:lstStyle/>
+          <a:p>
+            <a:endParaRPr lang="en-US"/>
+          </a:p>
+        </p:txBody>
       </p:sp>
       <p:sp>
         <p:nvSpPr>
@@ -7895,7 +7678,7 @@
           <a:bodyPr wrap="square" rtlCol="0" anchor="ctr"/>
           <a:lstStyle/>
           <a:p>
-            <a:pPr indent="0" marL="0">
+            <a:pPr marL="0" indent="0">
               <a:buNone/>
             </a:pPr>
             <a:r>
@@ -7915,15 +7698,15 @@
       </p:sp>
       <p:pic>
         <p:nvPicPr>
-          <p:cNvPr id="4" name="Image 0" descr="C:\Users\Kholwani\OneDrive - ADvTECH Ltd\BCAD 3\Sem 2\INSY7315\Part 2\emeris-pulse\docs\presentation-assets\24-admin-entry-granted.png">    </p:cNvPr>
+          <p:cNvPr id="4" name="Image 0" descr="C:\Users\Kholwani\OneDrive - ADvTECH Ltd\BCAD 3\Sem 2\INSY7315\Part 2\emeris-pulse\docs\presentation-assets\24-admin-entry-granted.png"/>
           <p:cNvPicPr>
             <a:picLocks noChangeAspect="1"/>
           </p:cNvPicPr>
           <p:nvPr/>
         </p:nvPicPr>
         <p:blipFill>
-          <a:blip r:embed="rId1"/>
-          <a:srcRect l="0" r="0" t="0" b="0"/>
+          <a:blip r:embed="rId3"/>
+          <a:srcRect/>
           <a:stretch/>
         </p:blipFill>
         <p:spPr>
@@ -7957,7 +7740,7 @@
           <a:bodyPr wrap="square" rtlCol="0" anchor="ctr"/>
           <a:lstStyle/>
           <a:p>
-            <a:pPr indent="0" marL="0">
+            <a:pPr marL="0" indent="0">
               <a:buNone/>
             </a:pPr>
             <a:r>
@@ -8019,6 +7802,13 @@
           </a:solidFill>
           <a:ln/>
         </p:spPr>
+        <p:txBody>
+          <a:bodyPr/>
+          <a:lstStyle/>
+          <a:p>
+            <a:endParaRPr lang="en-US"/>
+          </a:p>
+        </p:txBody>
       </p:sp>
       <p:sp>
         <p:nvSpPr>
@@ -8041,7 +7831,7 @@
           <a:bodyPr wrap="square" rtlCol="0" anchor="ctr"/>
           <a:lstStyle/>
           <a:p>
-            <a:pPr indent="0" marL="0">
+            <a:pPr marL="0" indent="0">
               <a:buNone/>
             </a:pPr>
             <a:r>
@@ -8061,15 +7851,15 @@
       </p:sp>
       <p:pic>
         <p:nvPicPr>
-          <p:cNvPr id="4" name="Image 0" descr="C:\Users\Kholwani\OneDrive - ADvTECH Ltd\BCAD 3\Sem 2\INSY7315\Part 2\emeris-pulse\docs\presentation-assets\25-member-youre-in.png">    </p:cNvPr>
+          <p:cNvPr id="4" name="Image 0" descr="C:\Users\Kholwani\OneDrive - ADvTECH Ltd\BCAD 3\Sem 2\INSY7315\Part 2\emeris-pulse\docs\presentation-assets\25-member-youre-in.png"/>
           <p:cNvPicPr>
             <a:picLocks noChangeAspect="1"/>
           </p:cNvPicPr>
           <p:nvPr/>
         </p:nvPicPr>
         <p:blipFill>
-          <a:blip r:embed="rId1"/>
-          <a:srcRect l="0" r="0" t="0" b="0"/>
+          <a:blip r:embed="rId3"/>
+          <a:srcRect/>
           <a:stretch/>
         </p:blipFill>
         <p:spPr>
@@ -8103,7 +7893,7 @@
           <a:bodyPr wrap="square" rtlCol="0" anchor="ctr"/>
           <a:lstStyle/>
           <a:p>
-            <a:pPr indent="0" marL="0">
+            <a:pPr marL="0" indent="0">
               <a:buNone/>
             </a:pPr>
             <a:r>
@@ -8165,6 +7955,13 @@
           </a:solidFill>
           <a:ln/>
         </p:spPr>
+        <p:txBody>
+          <a:bodyPr/>
+          <a:lstStyle/>
+          <a:p>
+            <a:endParaRPr lang="en-US"/>
+          </a:p>
+        </p:txBody>
       </p:sp>
       <p:sp>
         <p:nvSpPr>
@@ -8187,7 +7984,7 @@
           <a:bodyPr wrap="square" rtlCol="0" anchor="ctr"/>
           <a:lstStyle/>
           <a:p>
-            <a:pPr indent="0" marL="0">
+            <a:pPr marL="0" indent="0">
               <a:buNone/>
             </a:pPr>
             <a:r>
@@ -8343,6 +8140,13 @@
           </a:solidFill>
           <a:ln/>
         </p:spPr>
+        <p:txBody>
+          <a:bodyPr/>
+          <a:lstStyle/>
+          <a:p>
+            <a:endParaRPr lang="en-US"/>
+          </a:p>
+        </p:txBody>
       </p:sp>
       <p:sp>
         <p:nvSpPr>
@@ -8363,6 +8167,13 @@
           </a:solidFill>
           <a:ln/>
         </p:spPr>
+        <p:txBody>
+          <a:bodyPr/>
+          <a:lstStyle/>
+          <a:p>
+            <a:endParaRPr lang="en-US"/>
+          </a:p>
+        </p:txBody>
       </p:sp>
       <p:sp>
         <p:nvSpPr>
@@ -8385,7 +8196,7 @@
           <a:bodyPr wrap="square" rtlCol="0" anchor="ctr"/>
           <a:lstStyle/>
           <a:p>
-            <a:pPr indent="0" marL="0">
+            <a:pPr marL="0" indent="0">
               <a:buNone/>
             </a:pPr>
             <a:r>
@@ -8447,6 +8258,13 @@
           </a:solidFill>
           <a:ln/>
         </p:spPr>
+        <p:txBody>
+          <a:bodyPr/>
+          <a:lstStyle/>
+          <a:p>
+            <a:endParaRPr lang="en-US"/>
+          </a:p>
+        </p:txBody>
       </p:sp>
       <p:sp>
         <p:nvSpPr>
@@ -8469,7 +8287,7 @@
           <a:bodyPr wrap="square" rtlCol="0" anchor="ctr"/>
           <a:lstStyle/>
           <a:p>
-            <a:pPr indent="0" marL="0">
+            <a:pPr marL="0" indent="0">
               <a:buNone/>
             </a:pPr>
             <a:r>
@@ -8489,15 +8307,15 @@
       </p:sp>
       <p:pic>
         <p:nvPicPr>
-          <p:cNvPr id="4" name="Image 0" descr="C:\Users\Kholwani\OneDrive - ADvTECH Ltd\BCAD 3\Sem 2\INSY7315\Part 2\emeris-pulse\docs\presentation-assets\22-admin-dashboard.png">    </p:cNvPr>
+          <p:cNvPr id="4" name="Image 0" descr="C:\Users\Kholwani\OneDrive - ADvTECH Ltd\BCAD 3\Sem 2\INSY7315\Part 2\emeris-pulse\docs\presentation-assets\22-admin-dashboard.png"/>
           <p:cNvPicPr>
             <a:picLocks noChangeAspect="1"/>
           </p:cNvPicPr>
           <p:nvPr/>
         </p:nvPicPr>
         <p:blipFill>
-          <a:blip r:embed="rId1"/>
-          <a:srcRect l="0" r="0" t="0" b="0"/>
+          <a:blip r:embed="rId3"/>
+          <a:srcRect/>
           <a:stretch/>
         </p:blipFill>
         <p:spPr>
@@ -8531,7 +8349,7 @@
           <a:bodyPr wrap="square" rtlCol="0" anchor="ctr"/>
           <a:lstStyle/>
           <a:p>
-            <a:pPr indent="0" marL="0">
+            <a:pPr marL="0" indent="0">
               <a:buNone/>
             </a:pPr>
             <a:r>
@@ -8593,6 +8411,13 @@
           </a:solidFill>
           <a:ln/>
         </p:spPr>
+        <p:txBody>
+          <a:bodyPr/>
+          <a:lstStyle/>
+          <a:p>
+            <a:endParaRPr lang="en-US"/>
+          </a:p>
+        </p:txBody>
       </p:sp>
       <p:sp>
         <p:nvSpPr>
@@ -8615,7 +8440,7 @@
           <a:bodyPr wrap="square" rtlCol="0" anchor="ctr"/>
           <a:lstStyle/>
           <a:p>
-            <a:pPr indent="0" marL="0">
+            <a:pPr marL="0" indent="0">
               <a:buNone/>
             </a:pPr>
             <a:r>
@@ -8635,15 +8460,15 @@
       </p:sp>
       <p:pic>
         <p:nvPicPr>
-          <p:cNvPr id="4" name="Image 0" descr="C:\Users\Kholwani\OneDrive - ADvTECH Ltd\BCAD 3\Sem 2\INSY7315\Part 2\emeris-pulse\docs\presentation-assets\26-admin-access-logs.png">    </p:cNvPr>
+          <p:cNvPr id="4" name="Image 0" descr="C:\Users\Kholwani\OneDrive - ADvTECH Ltd\BCAD 3\Sem 2\INSY7315\Part 2\emeris-pulse\docs\presentation-assets\26-admin-access-logs.png"/>
           <p:cNvPicPr>
             <a:picLocks noChangeAspect="1"/>
           </p:cNvPicPr>
           <p:nvPr/>
         </p:nvPicPr>
         <p:blipFill>
-          <a:blip r:embed="rId1"/>
-          <a:srcRect l="0" r="0" t="0" b="0"/>
+          <a:blip r:embed="rId3"/>
+          <a:srcRect/>
           <a:stretch/>
         </p:blipFill>
         <p:spPr>
@@ -8677,7 +8502,7 @@
           <a:bodyPr wrap="square" rtlCol="0" anchor="ctr"/>
           <a:lstStyle/>
           <a:p>
-            <a:pPr indent="0" marL="0">
+            <a:pPr marL="0" indent="0">
               <a:buNone/>
             </a:pPr>
             <a:r>
@@ -8739,6 +8564,13 @@
           </a:solidFill>
           <a:ln/>
         </p:spPr>
+        <p:txBody>
+          <a:bodyPr/>
+          <a:lstStyle/>
+          <a:p>
+            <a:endParaRPr lang="en-US"/>
+          </a:p>
+        </p:txBody>
       </p:sp>
       <p:sp>
         <p:nvSpPr>
@@ -8761,7 +8593,7 @@
           <a:bodyPr wrap="square" rtlCol="0" anchor="ctr"/>
           <a:lstStyle/>
           <a:p>
-            <a:pPr indent="0" marL="0">
+            <a:pPr marL="0" indent="0">
               <a:buNone/>
             </a:pPr>
             <a:r>
@@ -8781,15 +8613,15 @@
       </p:sp>
       <p:pic>
         <p:nvPicPr>
-          <p:cNvPr id="4" name="Image 0" descr="C:\Users\Kholwani\OneDrive - ADvTECH Ltd\BCAD 3\Sem 2\INSY7315\Part 2\emeris-pulse\docs\presentation-assets\27-admin-members.png">    </p:cNvPr>
+          <p:cNvPr id="4" name="Image 0" descr="C:\Users\Kholwani\OneDrive - ADvTECH Ltd\BCAD 3\Sem 2\INSY7315\Part 2\emeris-pulse\docs\presentation-assets\27-admin-members.png"/>
           <p:cNvPicPr>
             <a:picLocks noChangeAspect="1"/>
           </p:cNvPicPr>
           <p:nvPr/>
         </p:nvPicPr>
         <p:blipFill>
-          <a:blip r:embed="rId1"/>
-          <a:srcRect l="0" r="0" t="0" b="0"/>
+          <a:blip r:embed="rId3"/>
+          <a:srcRect/>
           <a:stretch/>
         </p:blipFill>
         <p:spPr>
@@ -8823,7 +8655,7 @@
           <a:bodyPr wrap="square" rtlCol="0" anchor="ctr"/>
           <a:lstStyle/>
           <a:p>
-            <a:pPr indent="0" marL="0">
+            <a:pPr marL="0" indent="0">
               <a:buNone/>
             </a:pPr>
             <a:r>
@@ -8885,6 +8717,13 @@
           </a:solidFill>
           <a:ln/>
         </p:spPr>
+        <p:txBody>
+          <a:bodyPr/>
+          <a:lstStyle/>
+          <a:p>
+            <a:endParaRPr lang="en-US"/>
+          </a:p>
+        </p:txBody>
       </p:sp>
       <p:sp>
         <p:nvSpPr>
@@ -8907,7 +8746,7 @@
           <a:bodyPr wrap="square" rtlCol="0" anchor="ctr"/>
           <a:lstStyle/>
           <a:p>
-            <a:pPr indent="0" marL="0">
+            <a:pPr marL="0" indent="0">
               <a:buNone/>
             </a:pPr>
             <a:r>
@@ -8927,15 +8766,15 @@
       </p:sp>
       <p:pic>
         <p:nvPicPr>
-          <p:cNvPr id="4" name="Image 0" descr="C:\Users\Kholwani\OneDrive - ADvTECH Ltd\BCAD 3\Sem 2\INSY7315\Part 2\emeris-pulse\docs\presentation-assets\28-admin-temporary-pass.png">    </p:cNvPr>
+          <p:cNvPr id="4" name="Image 0" descr="C:\Users\Kholwani\OneDrive - ADvTECH Ltd\BCAD 3\Sem 2\INSY7315\Part 2\emeris-pulse\docs\presentation-assets\28-admin-temporary-pass.png"/>
           <p:cNvPicPr>
             <a:picLocks noChangeAspect="1"/>
           </p:cNvPicPr>
           <p:nvPr/>
         </p:nvPicPr>
         <p:blipFill>
-          <a:blip r:embed="rId1"/>
-          <a:srcRect l="0" r="0" t="0" b="0"/>
+          <a:blip r:embed="rId3"/>
+          <a:srcRect/>
           <a:stretch/>
         </p:blipFill>
         <p:spPr>
@@ -8969,7 +8808,7 @@
           <a:bodyPr wrap="square" rtlCol="0" anchor="ctr"/>
           <a:lstStyle/>
           <a:p>
-            <a:pPr indent="0" marL="0">
+            <a:pPr marL="0" indent="0">
               <a:buNone/>
             </a:pPr>
             <a:r>
@@ -9031,6 +8870,13 @@
           </a:solidFill>
           <a:ln/>
         </p:spPr>
+        <p:txBody>
+          <a:bodyPr/>
+          <a:lstStyle/>
+          <a:p>
+            <a:endParaRPr lang="en-US"/>
+          </a:p>
+        </p:txBody>
       </p:sp>
       <p:sp>
         <p:nvSpPr>
@@ -9053,7 +8899,7 @@
           <a:bodyPr wrap="square" rtlCol="0" anchor="ctr"/>
           <a:lstStyle/>
           <a:p>
-            <a:pPr indent="0" marL="0">
+            <a:pPr marL="0" indent="0">
               <a:buNone/>
             </a:pPr>
             <a:r>
@@ -9073,15 +8919,15 @@
       </p:sp>
       <p:pic>
         <p:nvPicPr>
-          <p:cNvPr id="4" name="Image 0" descr="C:\Users\Kholwani\OneDrive - ADvTECH Ltd\BCAD 3\Sem 2\INSY7315\Part 2\emeris-pulse\docs\presentation-assets\28b-admin-temporary-pass-issued.png">    </p:cNvPr>
+          <p:cNvPr id="4" name="Image 0" descr="C:\Users\Kholwani\OneDrive - ADvTECH Ltd\BCAD 3\Sem 2\INSY7315\Part 2\emeris-pulse\docs\presentation-assets\28b-admin-temporary-pass-issued.png"/>
           <p:cNvPicPr>
             <a:picLocks noChangeAspect="1"/>
           </p:cNvPicPr>
           <p:nvPr/>
         </p:nvPicPr>
         <p:blipFill>
-          <a:blip r:embed="rId1"/>
-          <a:srcRect l="0" r="0" t="0" b="0"/>
+          <a:blip r:embed="rId3"/>
+          <a:srcRect/>
           <a:stretch/>
         </p:blipFill>
         <p:spPr>
@@ -9115,7 +8961,7 @@
           <a:bodyPr wrap="square" rtlCol="0" anchor="ctr"/>
           <a:lstStyle/>
           <a:p>
-            <a:pPr indent="0" marL="0">
+            <a:pPr marL="0" indent="0">
               <a:buNone/>
             </a:pPr>
             <a:r>
@@ -9177,6 +9023,13 @@
           </a:solidFill>
           <a:ln/>
         </p:spPr>
+        <p:txBody>
+          <a:bodyPr/>
+          <a:lstStyle/>
+          <a:p>
+            <a:endParaRPr lang="en-US"/>
+          </a:p>
+        </p:txBody>
       </p:sp>
       <p:sp>
         <p:nvSpPr>
@@ -9199,7 +9052,7 @@
           <a:bodyPr wrap="square" rtlCol="0" anchor="ctr"/>
           <a:lstStyle/>
           <a:p>
-            <a:pPr indent="0" marL="0">
+            <a:pPr marL="0" indent="0">
               <a:buNone/>
             </a:pPr>
             <a:r>
@@ -9219,15 +9072,15 @@
       </p:sp>
       <p:pic>
         <p:nvPicPr>
-          <p:cNvPr id="4" name="Image 0" descr="C:\Users\Kholwani\OneDrive - ADvTECH Ltd\BCAD 3\Sem 2\INSY7315\Part 2\emeris-pulse\docs\presentation-assets\29-admin-timetable.png">    </p:cNvPr>
+          <p:cNvPr id="4" name="Image 0" descr="C:\Users\Kholwani\OneDrive - ADvTECH Ltd\BCAD 3\Sem 2\INSY7315\Part 2\emeris-pulse\docs\presentation-assets\29-admin-timetable.png"/>
           <p:cNvPicPr>
             <a:picLocks noChangeAspect="1"/>
           </p:cNvPicPr>
           <p:nvPr/>
         </p:nvPicPr>
         <p:blipFill>
-          <a:blip r:embed="rId1"/>
-          <a:srcRect l="0" r="0" t="0" b="0"/>
+          <a:blip r:embed="rId3"/>
+          <a:srcRect/>
           <a:stretch/>
         </p:blipFill>
         <p:spPr>
@@ -9261,7 +9114,7 @@
           <a:bodyPr wrap="square" rtlCol="0" anchor="ctr"/>
           <a:lstStyle/>
           <a:p>
-            <a:pPr indent="0" marL="0">
+            <a:pPr marL="0" indent="0">
               <a:buNone/>
             </a:pPr>
             <a:r>
@@ -9323,6 +9176,13 @@
           </a:solidFill>
           <a:ln/>
         </p:spPr>
+        <p:txBody>
+          <a:bodyPr/>
+          <a:lstStyle/>
+          <a:p>
+            <a:endParaRPr lang="en-US"/>
+          </a:p>
+        </p:txBody>
       </p:sp>
       <p:sp>
         <p:nvSpPr>
@@ -9345,7 +9205,7 @@
           <a:bodyPr wrap="square" rtlCol="0" anchor="ctr"/>
           <a:lstStyle/>
           <a:p>
-            <a:pPr indent="0" marL="0">
+            <a:pPr marL="0" indent="0">
               <a:buNone/>
             </a:pPr>
             <a:r>
@@ -9365,15 +9225,15 @@
       </p:sp>
       <p:pic>
         <p:nvPicPr>
-          <p:cNvPr id="4" name="Image 0" descr="C:\Users\Kholwani\OneDrive - ADvTECH Ltd\BCAD 3\Sem 2\INSY7315\Part 2\emeris-pulse\docs\presentation-assets\30-admin-challenges.png">    </p:cNvPr>
+          <p:cNvPr id="4" name="Image 0" descr="C:\Users\Kholwani\OneDrive - ADvTECH Ltd\BCAD 3\Sem 2\INSY7315\Part 2\emeris-pulse\docs\presentation-assets\30-admin-challenges.png"/>
           <p:cNvPicPr>
             <a:picLocks noChangeAspect="1"/>
           </p:cNvPicPr>
           <p:nvPr/>
         </p:nvPicPr>
         <p:blipFill>
-          <a:blip r:embed="rId1"/>
-          <a:srcRect l="0" r="0" t="0" b="0"/>
+          <a:blip r:embed="rId3"/>
+          <a:srcRect/>
           <a:stretch/>
         </p:blipFill>
         <p:spPr>
@@ -9407,7 +9267,7 @@
           <a:bodyPr wrap="square" rtlCol="0" anchor="ctr"/>
           <a:lstStyle/>
           <a:p>
-            <a:pPr indent="0" marL="0">
+            <a:pPr marL="0" indent="0">
               <a:buNone/>
             </a:pPr>
             <a:r>
@@ -9469,6 +9329,13 @@
           </a:solidFill>
           <a:ln/>
         </p:spPr>
+        <p:txBody>
+          <a:bodyPr/>
+          <a:lstStyle/>
+          <a:p>
+            <a:endParaRPr lang="en-US"/>
+          </a:p>
+        </p:txBody>
       </p:sp>
       <p:sp>
         <p:nvSpPr>
@@ -9491,7 +9358,7 @@
           <a:bodyPr wrap="square" rtlCol="0" anchor="ctr"/>
           <a:lstStyle/>
           <a:p>
-            <a:pPr indent="0" marL="0">
+            <a:pPr marL="0" indent="0">
               <a:buNone/>
             </a:pPr>
             <a:r>
@@ -9511,15 +9378,15 @@
       </p:sp>
       <p:pic>
         <p:nvPicPr>
-          <p:cNvPr id="4" name="Image 0" descr="C:\Users\Kholwani\OneDrive - ADvTECH Ltd\BCAD 3\Sem 2\INSY7315\Part 2\emeris-pulse\docs\presentation-assets\31-admin-broadcast.png">    </p:cNvPr>
+          <p:cNvPr id="4" name="Image 0" descr="C:\Users\Kholwani\OneDrive - ADvTECH Ltd\BCAD 3\Sem 2\INSY7315\Part 2\emeris-pulse\docs\presentation-assets\31-admin-broadcast.png"/>
           <p:cNvPicPr>
             <a:picLocks noChangeAspect="1"/>
           </p:cNvPicPr>
           <p:nvPr/>
         </p:nvPicPr>
         <p:blipFill>
-          <a:blip r:embed="rId1"/>
-          <a:srcRect l="0" r="0" t="0" b="0"/>
+          <a:blip r:embed="rId3"/>
+          <a:srcRect/>
           <a:stretch/>
         </p:blipFill>
         <p:spPr>
@@ -9553,7 +9420,7 @@
           <a:bodyPr wrap="square" rtlCol="0" anchor="ctr"/>
           <a:lstStyle/>
           <a:p>
-            <a:pPr indent="0" marL="0">
+            <a:pPr marL="0" indent="0">
               <a:buNone/>
             </a:pPr>
             <a:r>
@@ -9615,6 +9482,13 @@
           </a:solidFill>
           <a:ln/>
         </p:spPr>
+        <p:txBody>
+          <a:bodyPr/>
+          <a:lstStyle/>
+          <a:p>
+            <a:endParaRPr lang="en-US"/>
+          </a:p>
+        </p:txBody>
       </p:sp>
       <p:sp>
         <p:nvSpPr>
@@ -9637,7 +9511,7 @@
           <a:bodyPr wrap="square" rtlCol="0" anchor="ctr"/>
           <a:lstStyle/>
           <a:p>
-            <a:pPr indent="0" marL="0">
+            <a:pPr marL="0" indent="0">
               <a:buNone/>
             </a:pPr>
             <a:r>
@@ -9657,15 +9531,15 @@
       </p:sp>
       <p:pic>
         <p:nvPicPr>
-          <p:cNvPr id="4" name="Image 0" descr="C:\Users\Kholwani\OneDrive - ADvTECH Ltd\BCAD 3\Sem 2\INSY7315\Part 2\emeris-pulse\docs\presentation-assets\32-admin-reports.png">    </p:cNvPr>
+          <p:cNvPr id="4" name="Image 0" descr="C:\Users\Kholwani\OneDrive - ADvTECH Ltd\BCAD 3\Sem 2\INSY7315\Part 2\emeris-pulse\docs\presentation-assets\32-admin-reports.png"/>
           <p:cNvPicPr>
             <a:picLocks noChangeAspect="1"/>
           </p:cNvPicPr>
           <p:nvPr/>
         </p:nvPicPr>
         <p:blipFill>
-          <a:blip r:embed="rId1"/>
-          <a:srcRect l="0" r="0" t="0" b="0"/>
+          <a:blip r:embed="rId3"/>
+          <a:srcRect/>
           <a:stretch/>
         </p:blipFill>
         <p:spPr>
@@ -9699,7 +9573,7 @@
           <a:bodyPr wrap="square" rtlCol="0" anchor="ctr"/>
           <a:lstStyle/>
           <a:p>
-            <a:pPr indent="0" marL="0">
+            <a:pPr marL="0" indent="0">
               <a:buNone/>
             </a:pPr>
             <a:r>
@@ -9761,6 +9635,13 @@
           </a:solidFill>
           <a:ln/>
         </p:spPr>
+        <p:txBody>
+          <a:bodyPr/>
+          <a:lstStyle/>
+          <a:p>
+            <a:endParaRPr lang="en-US"/>
+          </a:p>
+        </p:txBody>
       </p:sp>
       <p:sp>
         <p:nvSpPr>
@@ -9781,6 +9662,13 @@
           </a:solidFill>
           <a:ln/>
         </p:spPr>
+        <p:txBody>
+          <a:bodyPr/>
+          <a:lstStyle/>
+          <a:p>
+            <a:endParaRPr lang="en-US"/>
+          </a:p>
+        </p:txBody>
       </p:sp>
       <p:sp>
         <p:nvSpPr>
@@ -9803,7 +9691,7 @@
           <a:bodyPr wrap="square" rtlCol="0" anchor="ctr"/>
           <a:lstStyle/>
           <a:p>
-            <a:pPr indent="0" marL="0">
+            <a:pPr marL="0" indent="0">
               <a:buNone/>
             </a:pPr>
             <a:r>
@@ -9865,6 +9753,13 @@
           </a:solidFill>
           <a:ln/>
         </p:spPr>
+        <p:txBody>
+          <a:bodyPr/>
+          <a:lstStyle/>
+          <a:p>
+            <a:endParaRPr lang="en-US"/>
+          </a:p>
+        </p:txBody>
       </p:sp>
       <p:sp>
         <p:nvSpPr>
@@ -9887,7 +9782,7 @@
           <a:bodyPr wrap="square" rtlCol="0" anchor="ctr"/>
           <a:lstStyle/>
           <a:p>
-            <a:pPr indent="0" marL="0">
+            <a:pPr marL="0" indent="0">
               <a:buNone/>
             </a:pPr>
             <a:r>
@@ -9907,15 +9802,15 @@
       </p:sp>
       <p:pic>
         <p:nvPicPr>
-          <p:cNvPr id="4" name="Image 0" descr="C:\Users\Kholwani\OneDrive - ADvTECH Ltd\BCAD 3\Sem 2\INSY7315\Part 2\emeris-pulse\docs\presentation-assets\33-admin-maintenance.png">    </p:cNvPr>
+          <p:cNvPr id="4" name="Image 0" descr="C:\Users\Kholwani\OneDrive - ADvTECH Ltd\BCAD 3\Sem 2\INSY7315\Part 2\emeris-pulse\docs\presentation-assets\33-admin-maintenance.png"/>
           <p:cNvPicPr>
             <a:picLocks noChangeAspect="1"/>
           </p:cNvPicPr>
           <p:nvPr/>
         </p:nvPicPr>
         <p:blipFill>
-          <a:blip r:embed="rId1"/>
-          <a:srcRect l="0" r="0" t="0" b="0"/>
+          <a:blip r:embed="rId3"/>
+          <a:srcRect/>
           <a:stretch/>
         </p:blipFill>
         <p:spPr>
@@ -9949,7 +9844,7 @@
           <a:bodyPr wrap="square" rtlCol="0" anchor="ctr"/>
           <a:lstStyle/>
           <a:p>
-            <a:pPr indent="0" marL="0">
+            <a:pPr marL="0" indent="0">
               <a:buNone/>
             </a:pPr>
             <a:r>
@@ -10011,6 +9906,13 @@
           </a:solidFill>
           <a:ln/>
         </p:spPr>
+        <p:txBody>
+          <a:bodyPr/>
+          <a:lstStyle/>
+          <a:p>
+            <a:endParaRPr lang="en-US"/>
+          </a:p>
+        </p:txBody>
       </p:sp>
       <p:sp>
         <p:nvSpPr>
@@ -10031,6 +9933,13 @@
           </a:solidFill>
           <a:ln/>
         </p:spPr>
+        <p:txBody>
+          <a:bodyPr/>
+          <a:lstStyle/>
+          <a:p>
+            <a:endParaRPr lang="en-US"/>
+          </a:p>
+        </p:txBody>
       </p:sp>
       <p:sp>
         <p:nvSpPr>
@@ -10053,7 +9962,7 @@
           <a:bodyPr wrap="square" rtlCol="0" anchor="ctr"/>
           <a:lstStyle/>
           <a:p>
-            <a:pPr indent="0" marL="0">
+            <a:pPr marL="0" indent="0">
               <a:buNone/>
             </a:pPr>
             <a:r>
@@ -10115,6 +10024,13 @@
           </a:solidFill>
           <a:ln/>
         </p:spPr>
+        <p:txBody>
+          <a:bodyPr/>
+          <a:lstStyle/>
+          <a:p>
+            <a:endParaRPr lang="en-US"/>
+          </a:p>
+        </p:txBody>
       </p:sp>
       <p:sp>
         <p:nvSpPr>
@@ -10137,7 +10053,7 @@
           <a:bodyPr wrap="square" rtlCol="0" anchor="ctr"/>
           <a:lstStyle/>
           <a:p>
-            <a:pPr indent="0" marL="0">
+            <a:pPr marL="0" indent="0">
               <a:buNone/>
             </a:pPr>
             <a:r>
@@ -10157,15 +10073,15 @@
       </p:sp>
       <p:pic>
         <p:nvPicPr>
-          <p:cNvPr id="4" name="Image 0" descr="C:\Users\Kholwani\OneDrive - ADvTECH Ltd\BCAD 3\Sem 2\INSY7315\Part 2\emeris-pulse\docs\presentation-assets\34-facility-dashboard.png">    </p:cNvPr>
+          <p:cNvPr id="4" name="Image 0" descr="C:\Users\Kholwani\OneDrive - ADvTECH Ltd\BCAD 3\Sem 2\INSY7315\Part 2\emeris-pulse\docs\presentation-assets\34-facility-dashboard.png"/>
           <p:cNvPicPr>
             <a:picLocks noChangeAspect="1"/>
           </p:cNvPicPr>
           <p:nvPr/>
         </p:nvPicPr>
         <p:blipFill>
-          <a:blip r:embed="rId1"/>
-          <a:srcRect l="0" r="0" t="0" b="0"/>
+          <a:blip r:embed="rId3"/>
+          <a:srcRect/>
           <a:stretch/>
         </p:blipFill>
         <p:spPr>
@@ -10199,7 +10115,7 @@
           <a:bodyPr wrap="square" rtlCol="0" anchor="ctr"/>
           <a:lstStyle/>
           <a:p>
-            <a:pPr indent="0" marL="0">
+            <a:pPr marL="0" indent="0">
               <a:buNone/>
             </a:pPr>
             <a:r>
@@ -10261,6 +10177,13 @@
           </a:solidFill>
           <a:ln/>
         </p:spPr>
+        <p:txBody>
+          <a:bodyPr/>
+          <a:lstStyle/>
+          <a:p>
+            <a:endParaRPr lang="en-US"/>
+          </a:p>
+        </p:txBody>
       </p:sp>
       <p:sp>
         <p:nvSpPr>
@@ -10283,7 +10206,7 @@
           <a:bodyPr wrap="square" rtlCol="0" anchor="ctr"/>
           <a:lstStyle/>
           <a:p>
-            <a:pPr indent="0" marL="0">
+            <a:pPr marL="0" indent="0">
               <a:buNone/>
             </a:pPr>
             <a:r>
@@ -10303,15 +10226,15 @@
       </p:sp>
       <p:pic>
         <p:nvPicPr>
-          <p:cNvPr id="4" name="Image 0" descr="C:\Users\Kholwani\OneDrive - ADvTECH Ltd\BCAD 3\Sem 2\INSY7315\Part 2\emeris-pulse\docs\presentation-assets\35-facility-maintenance.png">    </p:cNvPr>
+          <p:cNvPr id="4" name="Image 0" descr="C:\Users\Kholwani\OneDrive - ADvTECH Ltd\BCAD 3\Sem 2\INSY7315\Part 2\emeris-pulse\docs\presentation-assets\35-facility-maintenance.png"/>
           <p:cNvPicPr>
             <a:picLocks noChangeAspect="1"/>
           </p:cNvPicPr>
           <p:nvPr/>
         </p:nvPicPr>
         <p:blipFill>
-          <a:blip r:embed="rId1"/>
-          <a:srcRect l="0" r="0" t="0" b="0"/>
+          <a:blip r:embed="rId3"/>
+          <a:srcRect/>
           <a:stretch/>
         </p:blipFill>
         <p:spPr>
@@ -10345,7 +10268,7 @@
           <a:bodyPr wrap="square" rtlCol="0" anchor="ctr"/>
           <a:lstStyle/>
           <a:p>
-            <a:pPr indent="0" marL="0">
+            <a:pPr marL="0" indent="0">
               <a:buNone/>
             </a:pPr>
             <a:r>
@@ -10407,6 +10330,13 @@
           </a:solidFill>
           <a:ln/>
         </p:spPr>
+        <p:txBody>
+          <a:bodyPr/>
+          <a:lstStyle/>
+          <a:p>
+            <a:endParaRPr lang="en-US"/>
+          </a:p>
+        </p:txBody>
       </p:sp>
       <p:sp>
         <p:nvSpPr>
@@ -10429,7 +10359,7 @@
           <a:bodyPr wrap="square" rtlCol="0" anchor="ctr"/>
           <a:lstStyle/>
           <a:p>
-            <a:pPr indent="0" marL="0">
+            <a:pPr marL="0" indent="0">
               <a:buNone/>
             </a:pPr>
             <a:r>
@@ -10449,15 +10379,15 @@
       </p:sp>
       <p:pic>
         <p:nvPicPr>
-          <p:cNvPr id="4" name="Image 0" descr="C:\Users\Kholwani\OneDrive - ADvTECH Ltd\BCAD 3\Sem 2\INSY7315\Part 2\emeris-pulse\docs\presentation-assets\36-sysadmin-roles.png">    </p:cNvPr>
+          <p:cNvPr id="4" name="Image 0" descr="C:\Users\Kholwani\OneDrive - ADvTECH Ltd\BCAD 3\Sem 2\INSY7315\Part 2\emeris-pulse\docs\presentation-assets\36-sysadmin-roles.png"/>
           <p:cNvPicPr>
             <a:picLocks noChangeAspect="1"/>
           </p:cNvPicPr>
           <p:nvPr/>
         </p:nvPicPr>
         <p:blipFill>
-          <a:blip r:embed="rId1"/>
-          <a:srcRect l="0" r="0" t="0" b="0"/>
+          <a:blip r:embed="rId3"/>
+          <a:srcRect/>
           <a:stretch/>
         </p:blipFill>
         <p:spPr>
@@ -10491,7 +10421,7 @@
           <a:bodyPr wrap="square" rtlCol="0" anchor="ctr"/>
           <a:lstStyle/>
           <a:p>
-            <a:pPr indent="0" marL="0">
+            <a:pPr marL="0" indent="0">
               <a:buNone/>
             </a:pPr>
             <a:r>
@@ -10553,6 +10483,13 @@
           </a:solidFill>
           <a:ln/>
         </p:spPr>
+        <p:txBody>
+          <a:bodyPr/>
+          <a:lstStyle/>
+          <a:p>
+            <a:endParaRPr lang="en-US"/>
+          </a:p>
+        </p:txBody>
       </p:sp>
       <p:sp>
         <p:nvSpPr>
@@ -10575,7 +10512,7 @@
           <a:bodyPr wrap="square" rtlCol="0" anchor="ctr"/>
           <a:lstStyle/>
           <a:p>
-            <a:pPr indent="0" marL="0">
+            <a:pPr marL="0" indent="0">
               <a:buNone/>
             </a:pPr>
             <a:r>
@@ -10731,6 +10668,13 @@
           </a:solidFill>
           <a:ln/>
         </p:spPr>
+        <p:txBody>
+          <a:bodyPr/>
+          <a:lstStyle/>
+          <a:p>
+            <a:endParaRPr lang="en-US"/>
+          </a:p>
+        </p:txBody>
       </p:sp>
       <p:sp>
         <p:nvSpPr>
@@ -10753,7 +10697,7 @@
           <a:bodyPr wrap="square" rtlCol="0" anchor="ctr"/>
           <a:lstStyle/>
           <a:p>
-            <a:pPr indent="0" marL="0">
+            <a:pPr marL="0" indent="0">
               <a:buNone/>
             </a:pPr>
             <a:r>
@@ -10927,6 +10871,13 @@
           </a:solidFill>
           <a:ln/>
         </p:spPr>
+        <p:txBody>
+          <a:bodyPr/>
+          <a:lstStyle/>
+          <a:p>
+            <a:endParaRPr lang="en-US"/>
+          </a:p>
+        </p:txBody>
       </p:sp>
       <p:sp>
         <p:nvSpPr>
@@ -10949,7 +10900,7 @@
           <a:bodyPr wrap="square" rtlCol="0" anchor="ctr"/>
           <a:lstStyle/>
           <a:p>
-            <a:pPr indent="0" marL="0">
+            <a:pPr marL="0" indent="0">
               <a:buNone/>
             </a:pPr>
             <a:r>
@@ -11087,6 +11038,13 @@
           </a:solidFill>
           <a:ln/>
         </p:spPr>
+        <p:txBody>
+          <a:bodyPr/>
+          <a:lstStyle/>
+          <a:p>
+            <a:endParaRPr lang="en-US"/>
+          </a:p>
+        </p:txBody>
       </p:sp>
       <p:sp>
         <p:nvSpPr>
@@ -11109,7 +11067,7 @@
           <a:bodyPr wrap="square" rtlCol="0" anchor="ctr"/>
           <a:lstStyle/>
           <a:p>
-            <a:pPr indent="0" marL="0">
+            <a:pPr marL="0" indent="0">
               <a:buNone/>
             </a:pPr>
             <a:r>
@@ -11148,7 +11106,7 @@
           <a:bodyPr wrap="square" rtlCol="0" anchor="ctr"/>
           <a:lstStyle/>
           <a:p>
-            <a:pPr indent="0" marL="0">
+            <a:pPr marL="0" indent="0">
               <a:buNone/>
             </a:pPr>
             <a:r>
@@ -11210,6 +11168,13 @@
           </a:solidFill>
           <a:ln/>
         </p:spPr>
+        <p:txBody>
+          <a:bodyPr/>
+          <a:lstStyle/>
+          <a:p>
+            <a:endParaRPr lang="en-US"/>
+          </a:p>
+        </p:txBody>
       </p:sp>
       <p:sp>
         <p:nvSpPr>
@@ -11232,7 +11197,7 @@
           <a:bodyPr wrap="square" rtlCol="0" anchor="ctr"/>
           <a:lstStyle/>
           <a:p>
-            <a:pPr indent="0" marL="0">
+            <a:pPr marL="0" indent="0">
               <a:buNone/>
             </a:pPr>
             <a:r>
@@ -11252,15 +11217,15 @@
       </p:sp>
       <p:pic>
         <p:nvPicPr>
-          <p:cNvPr id="4" name="Image 0" descr="C:\Users\Kholwani\OneDrive - ADvTECH Ltd\BCAD 3\Sem 2\INSY7315\Part 2\emeris-pulse\docs\presentation-assets\01-member-phone-login.png">    </p:cNvPr>
+          <p:cNvPr id="4" name="Image 0" descr="C:\Users\Kholwani\OneDrive - ADvTECH Ltd\BCAD 3\Sem 2\INSY7315\Part 2\emeris-pulse\docs\presentation-assets\01-member-phone-login.png"/>
           <p:cNvPicPr>
             <a:picLocks noChangeAspect="1"/>
           </p:cNvPicPr>
           <p:nvPr/>
         </p:nvPicPr>
         <p:blipFill>
-          <a:blip r:embed="rId1"/>
-          <a:srcRect l="0" r="0" t="0" b="0"/>
+          <a:blip r:embed="rId3"/>
+          <a:srcRect/>
           <a:stretch/>
         </p:blipFill>
         <p:spPr>
@@ -11294,7 +11259,7 @@
           <a:bodyPr wrap="square" rtlCol="0" anchor="ctr"/>
           <a:lstStyle/>
           <a:p>
-            <a:pPr indent="0" marL="0">
+            <a:pPr marL="0" indent="0">
               <a:buNone/>
             </a:pPr>
             <a:r>
@@ -11356,6 +11321,13 @@
           </a:solidFill>
           <a:ln/>
         </p:spPr>
+        <p:txBody>
+          <a:bodyPr/>
+          <a:lstStyle/>
+          <a:p>
+            <a:endParaRPr lang="en-US"/>
+          </a:p>
+        </p:txBody>
       </p:sp>
       <p:sp>
         <p:nvSpPr>
@@ -11378,7 +11350,7 @@
           <a:bodyPr wrap="square" rtlCol="0" anchor="ctr"/>
           <a:lstStyle/>
           <a:p>
-            <a:pPr indent="0" marL="0">
+            <a:pPr marL="0" indent="0">
               <a:buNone/>
             </a:pPr>
             <a:r>
@@ -11417,7 +11389,7 @@
           <a:bodyPr wrap="square" rtlCol="0" anchor="ctr"/>
           <a:lstStyle/>
           <a:p>
-            <a:pPr indent="0" marL="0">
+            <a:pPr marL="0" indent="0">
               <a:buNone/>
             </a:pPr>
             <a:r>
@@ -11437,15 +11409,15 @@
       </p:sp>
       <p:pic>
         <p:nvPicPr>
-          <p:cNvPr id="5" name="Image 0" descr="C:\Users\Kholwani\OneDrive - ADvTECH Ltd\BCAD 3\Sem 2\INSY7315\Part 2\emeris-pulse\docs\presentation-assets\02-member-phone-home.png">    </p:cNvPr>
+          <p:cNvPr id="5" name="Image 0" descr="C:\Users\Kholwani\OneDrive - ADvTECH Ltd\BCAD 3\Sem 2\INSY7315\Part 2\emeris-pulse\docs\presentation-assets\02-member-phone-home.png"/>
           <p:cNvPicPr>
             <a:picLocks noChangeAspect="1"/>
           </p:cNvPicPr>
           <p:nvPr/>
         </p:nvPicPr>
         <p:blipFill>
-          <a:blip r:embed="rId1"/>
-          <a:srcRect l="0" r="0" t="0" b="0"/>
+          <a:blip r:embed="rId3"/>
+          <a:srcRect/>
           <a:stretch/>
         </p:blipFill>
         <p:spPr>
@@ -11479,7 +11451,7 @@
           <a:bodyPr wrap="square" rtlCol="0" anchor="ctr"/>
           <a:lstStyle/>
           <a:p>
-            <a:pPr indent="0" marL="0">
+            <a:pPr marL="0" indent="0">
               <a:buNone/>
             </a:pPr>
             <a:r>
@@ -11499,15 +11471,15 @@
       </p:sp>
       <p:pic>
         <p:nvPicPr>
-          <p:cNvPr id="7" name="Image 1" descr="C:\Users\Kholwani\OneDrive - ADvTECH Ltd\BCAD 3\Sem 2\INSY7315\Part 2\emeris-pulse\docs\presentation-assets\11-member-desktop-home.png">    </p:cNvPr>
+          <p:cNvPr id="7" name="Image 1" descr="C:\Users\Kholwani\OneDrive - ADvTECH Ltd\BCAD 3\Sem 2\INSY7315\Part 2\emeris-pulse\docs\presentation-assets\11-member-desktop-home.png"/>
           <p:cNvPicPr>
             <a:picLocks noChangeAspect="1"/>
           </p:cNvPicPr>
           <p:nvPr/>
         </p:nvPicPr>
         <p:blipFill>
-          <a:blip r:embed="rId2"/>
-          <a:srcRect l="0" r="0" t="0" b="0"/>
+          <a:blip r:embed="rId4"/>
+          <a:srcRect/>
           <a:stretch/>
         </p:blipFill>
         <p:spPr>
@@ -11541,7 +11513,7 @@
           <a:bodyPr wrap="square" rtlCol="0" anchor="ctr"/>
           <a:lstStyle/>
           <a:p>
-            <a:pPr indent="0" marL="0">
+            <a:pPr marL="0" indent="0">
               <a:buNone/>
             </a:pPr>
             <a:r>
@@ -11603,6 +11575,13 @@
           </a:solidFill>
           <a:ln/>
         </p:spPr>
+        <p:txBody>
+          <a:bodyPr/>
+          <a:lstStyle/>
+          <a:p>
+            <a:endParaRPr lang="en-US"/>
+          </a:p>
+        </p:txBody>
       </p:sp>
       <p:sp>
         <p:nvSpPr>
@@ -11625,7 +11604,7 @@
           <a:bodyPr wrap="square" rtlCol="0" anchor="ctr"/>
           <a:lstStyle/>
           <a:p>
-            <a:pPr indent="0" marL="0">
+            <a:pPr marL="0" indent="0">
               <a:buNone/>
             </a:pPr>
             <a:r>
@@ -11664,7 +11643,7 @@
           <a:bodyPr wrap="square" rtlCol="0" anchor="ctr"/>
           <a:lstStyle/>
           <a:p>
-            <a:pPr indent="0" marL="0">
+            <a:pPr marL="0" indent="0">
               <a:buNone/>
             </a:pPr>
             <a:r>
@@ -11684,15 +11663,15 @@
       </p:sp>
       <p:pic>
         <p:nvPicPr>
-          <p:cNvPr id="5" name="Image 0" descr="C:\Users\Kholwani\OneDrive - ADvTECH Ltd\BCAD 3\Sem 2\INSY7315\Part 2\emeris-pulse\docs\presentation-assets\03-member-phone-access.png">    </p:cNvPr>
+          <p:cNvPr id="5" name="Image 0" descr="C:\Users\Kholwani\OneDrive - ADvTECH Ltd\BCAD 3\Sem 2\INSY7315\Part 2\emeris-pulse\docs\presentation-assets\03-member-phone-access.png"/>
           <p:cNvPicPr>
             <a:picLocks noChangeAspect="1"/>
           </p:cNvPicPr>
           <p:nvPr/>
         </p:nvPicPr>
         <p:blipFill>
-          <a:blip r:embed="rId1"/>
-          <a:srcRect l="0" r="0" t="0" b="0"/>
+          <a:blip r:embed="rId3"/>
+          <a:srcRect/>
           <a:stretch/>
         </p:blipFill>
         <p:spPr>
@@ -11726,7 +11705,7 @@
           <a:bodyPr wrap="square" rtlCol="0" anchor="ctr"/>
           <a:lstStyle/>
           <a:p>
-            <a:pPr indent="0" marL="0">
+            <a:pPr marL="0" indent="0">
               <a:buNone/>
             </a:pPr>
             <a:r>
@@ -11746,15 +11725,15 @@
       </p:sp>
       <p:pic>
         <p:nvPicPr>
-          <p:cNvPr id="7" name="Image 1" descr="C:\Users\Kholwani\OneDrive - ADvTECH Ltd\BCAD 3\Sem 2\INSY7315\Part 2\emeris-pulse\docs\presentation-assets\12-member-desktop-access.png">    </p:cNvPr>
+          <p:cNvPr id="7" name="Image 1" descr="C:\Users\Kholwani\OneDrive - ADvTECH Ltd\BCAD 3\Sem 2\INSY7315\Part 2\emeris-pulse\docs\presentation-assets\12-member-desktop-access.png"/>
           <p:cNvPicPr>
             <a:picLocks noChangeAspect="1"/>
           </p:cNvPicPr>
           <p:nvPr/>
         </p:nvPicPr>
         <p:blipFill>
-          <a:blip r:embed="rId2"/>
-          <a:srcRect l="0" r="0" t="0" b="0"/>
+          <a:blip r:embed="rId4"/>
+          <a:srcRect/>
           <a:stretch/>
         </p:blipFill>
         <p:spPr>
@@ -11788,7 +11767,7 @@
           <a:bodyPr wrap="square" rtlCol="0" anchor="ctr"/>
           <a:lstStyle/>
           <a:p>
-            <a:pPr indent="0" marL="0">
+            <a:pPr marL="0" indent="0">
               <a:buNone/>
             </a:pPr>
             <a:r>
@@ -11850,6 +11829,13 @@
           </a:solidFill>
           <a:ln/>
         </p:spPr>
+        <p:txBody>
+          <a:bodyPr/>
+          <a:lstStyle/>
+          <a:p>
+            <a:endParaRPr lang="en-US"/>
+          </a:p>
+        </p:txBody>
       </p:sp>
       <p:sp>
         <p:nvSpPr>
@@ -11872,7 +11858,7 @@
           <a:bodyPr wrap="square" rtlCol="0" anchor="ctr"/>
           <a:lstStyle/>
           <a:p>
-            <a:pPr indent="0" marL="0">
+            <a:pPr marL="0" indent="0">
               <a:buNone/>
             </a:pPr>
             <a:r>
@@ -11911,7 +11897,7 @@
           <a:bodyPr wrap="square" rtlCol="0" anchor="ctr"/>
           <a:lstStyle/>
           <a:p>
-            <a:pPr indent="0" marL="0">
+            <a:pPr marL="0" indent="0">
               <a:buNone/>
             </a:pPr>
             <a:r>
@@ -11931,15 +11917,15 @@
       </p:sp>
       <p:pic>
         <p:nvPicPr>
-          <p:cNvPr id="5" name="Image 0" descr="C:\Users\Kholwani\OneDrive - ADvTECH Ltd\BCAD 3\Sem 2\INSY7315\Part 2\emeris-pulse\docs\presentation-assets\04-member-phone-classes.png">    </p:cNvPr>
+          <p:cNvPr id="5" name="Image 0" descr="C:\Users\Kholwani\OneDrive - ADvTECH Ltd\BCAD 3\Sem 2\INSY7315\Part 2\emeris-pulse\docs\presentation-assets\04-member-phone-classes.png"/>
           <p:cNvPicPr>
             <a:picLocks noChangeAspect="1"/>
           </p:cNvPicPr>
           <p:nvPr/>
         </p:nvPicPr>
         <p:blipFill>
-          <a:blip r:embed="rId1"/>
-          <a:srcRect l="0" r="0" t="0" b="0"/>
+          <a:blip r:embed="rId3"/>
+          <a:srcRect/>
           <a:stretch/>
         </p:blipFill>
         <p:spPr>
@@ -11973,7 +11959,7 @@
           <a:bodyPr wrap="square" rtlCol="0" anchor="ctr"/>
           <a:lstStyle/>
           <a:p>
-            <a:pPr indent="0" marL="0">
+            <a:pPr marL="0" indent="0">
               <a:buNone/>
             </a:pPr>
             <a:r>
@@ -11993,15 +11979,15 @@
       </p:sp>
       <p:pic>
         <p:nvPicPr>
-          <p:cNvPr id="7" name="Image 1" descr="C:\Users\Kholwani\OneDrive - ADvTECH Ltd\BCAD 3\Sem 2\INSY7315\Part 2\emeris-pulse\docs\presentation-assets\13-member-desktop-classes.png">    </p:cNvPr>
+          <p:cNvPr id="7" name="Image 1" descr="C:\Users\Kholwani\OneDrive - ADvTECH Ltd\BCAD 3\Sem 2\INSY7315\Part 2\emeris-pulse\docs\presentation-assets\13-member-desktop-classes.png"/>
           <p:cNvPicPr>
             <a:picLocks noChangeAspect="1"/>
           </p:cNvPicPr>
           <p:nvPr/>
         </p:nvPicPr>
         <p:blipFill>
-          <a:blip r:embed="rId2"/>
-          <a:srcRect l="0" r="0" t="0" b="0"/>
+          <a:blip r:embed="rId4"/>
+          <a:srcRect/>
           <a:stretch/>
         </p:blipFill>
         <p:spPr>
@@ -12035,7 +12021,7 @@
           <a:bodyPr wrap="square" rtlCol="0" anchor="ctr"/>
           <a:lstStyle/>
           <a:p>
-            <a:pPr indent="0" marL="0">
+            <a:pPr marL="0" indent="0">
               <a:buNone/>
             </a:pPr>
             <a:r>
@@ -12097,6 +12083,13 @@
           </a:solidFill>
           <a:ln/>
         </p:spPr>
+        <p:txBody>
+          <a:bodyPr/>
+          <a:lstStyle/>
+          <a:p>
+            <a:endParaRPr lang="en-US"/>
+          </a:p>
+        </p:txBody>
       </p:sp>
       <p:sp>
         <p:nvSpPr>
@@ -12119,7 +12112,7 @@
           <a:bodyPr wrap="square" rtlCol="0" anchor="ctr"/>
           <a:lstStyle/>
           <a:p>
-            <a:pPr indent="0" marL="0">
+            <a:pPr marL="0" indent="0">
               <a:buNone/>
             </a:pPr>
             <a:r>
@@ -12139,15 +12132,15 @@
       </p:sp>
       <p:pic>
         <p:nvPicPr>
-          <p:cNvPr id="4" name="Image 0" descr="C:\Users\Kholwani\OneDrive - ADvTECH Ltd\BCAD 3\Sem 2\INSY7315\Part 2\emeris-pulse\docs\presentation-assets\05-member-phone-more.png">    </p:cNvPr>
+          <p:cNvPr id="4" name="Image 0" descr="C:\Users\Kholwani\OneDrive - ADvTECH Ltd\BCAD 3\Sem 2\INSY7315\Part 2\emeris-pulse\docs\presentation-assets\05-member-phone-more.png"/>
           <p:cNvPicPr>
             <a:picLocks noChangeAspect="1"/>
           </p:cNvPicPr>
           <p:nvPr/>
         </p:nvPicPr>
         <p:blipFill>
-          <a:blip r:embed="rId1"/>
-          <a:srcRect l="0" r="0" t="0" b="0"/>
+          <a:blip r:embed="rId3"/>
+          <a:srcRect/>
           <a:stretch/>
         </p:blipFill>
         <p:spPr>
@@ -12181,7 +12174,7 @@
           <a:bodyPr wrap="square" rtlCol="0" anchor="ctr"/>
           <a:lstStyle/>
           <a:p>
-            <a:pPr indent="0" marL="0">
+            <a:pPr marL="0" indent="0">
               <a:buNone/>
             </a:pPr>
             <a:r>
@@ -12500,4 +12493,319 @@
     </a:ext>
   </a:extLst>
 </a:theme>
+</file>
+
+<file path=ppt/theme/theme2.xml><?xml version="1.0" encoding="utf-8"?>
+<a:theme xmlns:a="http://schemas.openxmlformats.org/drawingml/2006/main" name="Office Theme">
+  <a:themeElements>
+    <a:clrScheme name="Office">
+      <a:dk1>
+        <a:sysClr val="windowText" lastClr="000000"/>
+      </a:dk1>
+      <a:lt1>
+        <a:sysClr val="window" lastClr="FFFFFF"/>
+      </a:lt1>
+      <a:dk2>
+        <a:srgbClr val="0E2841"/>
+      </a:dk2>
+      <a:lt2>
+        <a:srgbClr val="E8E8E8"/>
+      </a:lt2>
+      <a:accent1>
+        <a:srgbClr val="156082"/>
+      </a:accent1>
+      <a:accent2>
+        <a:srgbClr val="E97132"/>
+      </a:accent2>
+      <a:accent3>
+        <a:srgbClr val="196B24"/>
+      </a:accent3>
+      <a:accent4>
+        <a:srgbClr val="0F9ED5"/>
+      </a:accent4>
+      <a:accent5>
+        <a:srgbClr val="A02B93"/>
+      </a:accent5>
+      <a:accent6>
+        <a:srgbClr val="4EA72E"/>
+      </a:accent6>
+      <a:hlink>
+        <a:srgbClr val="467886"/>
+      </a:hlink>
+      <a:folHlink>
+        <a:srgbClr val="96607D"/>
+      </a:folHlink>
+    </a:clrScheme>
+    <a:fontScheme name="Office">
+      <a:majorFont>
+        <a:latin typeface="Aptos Display" panose="02110004020202020204"/>
+        <a:ea typeface=""/>
+        <a:cs typeface=""/>
+        <a:font script="Jpan" typeface="游ゴシック Light"/>
+        <a:font script="Hang" typeface="맑은 고딕"/>
+        <a:font script="Hans" typeface="等线 Light"/>
+        <a:font script="Hant" typeface="新細明體"/>
+        <a:font script="Arab" typeface="Times New Roman"/>
+        <a:font script="Hebr" typeface="Times New Roman"/>
+        <a:font script="Thai" typeface="Angsana New"/>
+        <a:font script="Ethi" typeface="Nyala"/>
+        <a:font script="Beng" typeface="Vrinda"/>
+        <a:font script="Gujr" typeface="Shruti"/>
+        <a:font script="Khmr" typeface="MoolBoran"/>
+        <a:font script="Knda" typeface="Tunga"/>
+        <a:font script="Guru" typeface="Raavi"/>
+        <a:font script="Cans" typeface="Euphemia"/>
+        <a:font script="Cher" typeface="Plantagenet Cherokee"/>
+        <a:font script="Yiii" typeface="Microsoft Yi Baiti"/>
+        <a:font script="Tibt" typeface="Microsoft Himalaya"/>
+        <a:font script="Thaa" typeface="MV Boli"/>
+        <a:font script="Deva" typeface="Mangal"/>
+        <a:font script="Telu" typeface="Gautami"/>
+        <a:font script="Taml" typeface="Latha"/>
+        <a:font script="Syrc" typeface="Estrangelo Edessa"/>
+        <a:font script="Orya" typeface="Kalinga"/>
+        <a:font script="Mlym" typeface="Kartika"/>
+        <a:font script="Laoo" typeface="DokChampa"/>
+        <a:font script="Sinh" typeface="Iskoola Pota"/>
+        <a:font script="Mong" typeface="Mongolian Baiti"/>
+        <a:font script="Viet" typeface="Times New Roman"/>
+        <a:font script="Uigh" typeface="Microsoft Uighur"/>
+        <a:font script="Geor" typeface="Sylfaen"/>
+        <a:font script="Armn" typeface="Arial"/>
+        <a:font script="Bugi" typeface="Leelawadee UI"/>
+        <a:font script="Bopo" typeface="Microsoft JhengHei"/>
+        <a:font script="Java" typeface="Javanese Text"/>
+        <a:font script="Lisu" typeface="Segoe UI"/>
+        <a:font script="Mymr" typeface="Myanmar Text"/>
+        <a:font script="Nkoo" typeface="Ebrima"/>
+        <a:font script="Olck" typeface="Nirmala UI"/>
+        <a:font script="Osma" typeface="Ebrima"/>
+        <a:font script="Phag" typeface="Phagspa"/>
+        <a:font script="Syrn" typeface="Estrangelo Edessa"/>
+        <a:font script="Syrj" typeface="Estrangelo Edessa"/>
+        <a:font script="Syre" typeface="Estrangelo Edessa"/>
+        <a:font script="Sora" typeface="Nirmala UI"/>
+        <a:font script="Tale" typeface="Microsoft Tai Le"/>
+        <a:font script="Talu" typeface="Microsoft New Tai Lue"/>
+        <a:font script="Tfng" typeface="Ebrima"/>
+      </a:majorFont>
+      <a:minorFont>
+        <a:latin typeface="Aptos" panose="02110004020202020204"/>
+        <a:ea typeface=""/>
+        <a:cs typeface=""/>
+        <a:font script="Jpan" typeface="游ゴシック"/>
+        <a:font script="Hang" typeface="맑은 고딕"/>
+        <a:font script="Hans" typeface="等线"/>
+        <a:font script="Hant" typeface="新細明體"/>
+        <a:font script="Arab" typeface="Arial"/>
+        <a:font script="Hebr" typeface="Arial"/>
+        <a:font script="Thai" typeface="Cordia New"/>
+        <a:font script="Ethi" typeface="Nyala"/>
+        <a:font script="Beng" typeface="Vrinda"/>
+        <a:font script="Gujr" typeface="Shruti"/>
+        <a:font script="Khmr" typeface="DaunPenh"/>
+        <a:font script="Knda" typeface="Tunga"/>
+        <a:font script="Guru" typeface="Raavi"/>
+        <a:font script="Cans" typeface="Euphemia"/>
+        <a:font script="Cher" typeface="Plantagenet Cherokee"/>
+        <a:font script="Yiii" typeface="Microsoft Yi Baiti"/>
+        <a:font script="Tibt" typeface="Microsoft Himalaya"/>
+        <a:font script="Thaa" typeface="MV Boli"/>
+        <a:font script="Deva" typeface="Mangal"/>
+        <a:font script="Telu" typeface="Gautami"/>
+        <a:font script="Taml" typeface="Latha"/>
+        <a:font script="Syrc" typeface="Estrangelo Edessa"/>
+        <a:font script="Orya" typeface="Kalinga"/>
+        <a:font script="Mlym" typeface="Kartika"/>
+        <a:font script="Laoo" typeface="DokChampa"/>
+        <a:font script="Sinh" typeface="Iskoola Pota"/>
+        <a:font script="Mong" typeface="Mongolian Baiti"/>
+        <a:font script="Viet" typeface="Arial"/>
+        <a:font script="Uigh" typeface="Microsoft Uighur"/>
+        <a:font script="Geor" typeface="Sylfaen"/>
+        <a:font script="Armn" typeface="Arial"/>
+        <a:font script="Bugi" typeface="Leelawadee UI"/>
+        <a:font script="Bopo" typeface="Microsoft JhengHei"/>
+        <a:font script="Java" typeface="Javanese Text"/>
+        <a:font script="Lisu" typeface="Segoe UI"/>
+        <a:font script="Mymr" typeface="Myanmar Text"/>
+        <a:font script="Nkoo" typeface="Ebrima"/>
+        <a:font script="Olck" typeface="Nirmala UI"/>
+        <a:font script="Osma" typeface="Ebrima"/>
+        <a:font script="Phag" typeface="Phagspa"/>
+        <a:font script="Syrn" typeface="Estrangelo Edessa"/>
+        <a:font script="Syrj" typeface="Estrangelo Edessa"/>
+        <a:font script="Syre" typeface="Estrangelo Edessa"/>
+        <a:font script="Sora" typeface="Nirmala UI"/>
+        <a:font script="Tale" typeface="Microsoft Tai Le"/>
+        <a:font script="Talu" typeface="Microsoft New Tai Lue"/>
+        <a:font script="Tfng" typeface="Ebrima"/>
+      </a:minorFont>
+    </a:fontScheme>
+    <a:fmtScheme name="Office">
+      <a:fillStyleLst>
+        <a:solidFill>
+          <a:schemeClr val="phClr"/>
+        </a:solidFill>
+        <a:gradFill rotWithShape="1">
+          <a:gsLst>
+            <a:gs pos="0">
+              <a:schemeClr val="phClr">
+                <a:lumMod val="110000"/>
+                <a:satMod val="105000"/>
+                <a:tint val="67000"/>
+              </a:schemeClr>
+            </a:gs>
+            <a:gs pos="50000">
+              <a:schemeClr val="phClr">
+                <a:lumMod val="105000"/>
+                <a:satMod val="103000"/>
+                <a:tint val="73000"/>
+              </a:schemeClr>
+            </a:gs>
+            <a:gs pos="100000">
+              <a:schemeClr val="phClr">
+                <a:lumMod val="105000"/>
+                <a:satMod val="109000"/>
+                <a:tint val="81000"/>
+              </a:schemeClr>
+            </a:gs>
+          </a:gsLst>
+          <a:lin ang="5400000" scaled="0"/>
+        </a:gradFill>
+        <a:gradFill rotWithShape="1">
+          <a:gsLst>
+            <a:gs pos="0">
+              <a:schemeClr val="phClr">
+                <a:satMod val="103000"/>
+                <a:lumMod val="102000"/>
+                <a:tint val="94000"/>
+              </a:schemeClr>
+            </a:gs>
+            <a:gs pos="50000">
+              <a:schemeClr val="phClr">
+                <a:satMod val="110000"/>
+                <a:lumMod val="100000"/>
+                <a:shade val="100000"/>
+              </a:schemeClr>
+            </a:gs>
+            <a:gs pos="100000">
+              <a:schemeClr val="phClr">
+                <a:lumMod val="99000"/>
+                <a:satMod val="120000"/>
+                <a:shade val="78000"/>
+              </a:schemeClr>
+            </a:gs>
+          </a:gsLst>
+          <a:lin ang="5400000" scaled="0"/>
+        </a:gradFill>
+      </a:fillStyleLst>
+      <a:lnStyleLst>
+        <a:ln w="12700" cap="flat" cmpd="sng" algn="ctr">
+          <a:solidFill>
+            <a:schemeClr val="phClr"/>
+          </a:solidFill>
+          <a:prstDash val="solid"/>
+          <a:miter lim="800000"/>
+        </a:ln>
+        <a:ln w="19050" cap="flat" cmpd="sng" algn="ctr">
+          <a:solidFill>
+            <a:schemeClr val="phClr"/>
+          </a:solidFill>
+          <a:prstDash val="solid"/>
+          <a:miter lim="800000"/>
+        </a:ln>
+        <a:ln w="25400" cap="flat" cmpd="sng" algn="ctr">
+          <a:solidFill>
+            <a:schemeClr val="phClr"/>
+          </a:solidFill>
+          <a:prstDash val="solid"/>
+          <a:miter lim="800000"/>
+        </a:ln>
+      </a:lnStyleLst>
+      <a:effectStyleLst>
+        <a:effectStyle>
+          <a:effectLst/>
+        </a:effectStyle>
+        <a:effectStyle>
+          <a:effectLst/>
+        </a:effectStyle>
+        <a:effectStyle>
+          <a:effectLst>
+            <a:outerShdw blurRad="57150" dist="19050" dir="5400000" algn="ctr" rotWithShape="0">
+              <a:srgbClr val="000000">
+                <a:alpha val="63000"/>
+              </a:srgbClr>
+            </a:outerShdw>
+          </a:effectLst>
+        </a:effectStyle>
+      </a:effectStyleLst>
+      <a:bgFillStyleLst>
+        <a:solidFill>
+          <a:schemeClr val="phClr"/>
+        </a:solidFill>
+        <a:solidFill>
+          <a:schemeClr val="phClr">
+            <a:tint val="95000"/>
+            <a:satMod val="170000"/>
+          </a:schemeClr>
+        </a:solidFill>
+        <a:gradFill rotWithShape="1">
+          <a:gsLst>
+            <a:gs pos="0">
+              <a:schemeClr val="phClr">
+                <a:tint val="93000"/>
+                <a:satMod val="150000"/>
+                <a:shade val="98000"/>
+                <a:lumMod val="102000"/>
+              </a:schemeClr>
+            </a:gs>
+            <a:gs pos="50000">
+              <a:schemeClr val="phClr">
+                <a:tint val="98000"/>
+                <a:satMod val="130000"/>
+                <a:shade val="90000"/>
+                <a:lumMod val="103000"/>
+              </a:schemeClr>
+            </a:gs>
+            <a:gs pos="100000">
+              <a:schemeClr val="phClr">
+                <a:shade val="63000"/>
+                <a:satMod val="120000"/>
+              </a:schemeClr>
+            </a:gs>
+          </a:gsLst>
+          <a:lin ang="5400000" scaled="0"/>
+        </a:gradFill>
+      </a:bgFillStyleLst>
+    </a:fmtScheme>
+  </a:themeElements>
+  <a:objectDefaults>
+    <a:lnDef>
+      <a:spPr/>
+      <a:bodyPr/>
+      <a:lstStyle/>
+      <a:style>
+        <a:lnRef idx="2">
+          <a:schemeClr val="accent1"/>
+        </a:lnRef>
+        <a:fillRef idx="0">
+          <a:schemeClr val="accent1"/>
+        </a:fillRef>
+        <a:effectRef idx="1">
+          <a:schemeClr val="accent1"/>
+        </a:effectRef>
+        <a:fontRef idx="minor">
+          <a:schemeClr val="tx1"/>
+        </a:fontRef>
+      </a:style>
+    </a:lnDef>
+  </a:objectDefaults>
+  <a:extraClrSchemeLst/>
+  <a:extLst>
+    <a:ext uri="{05A4C25C-085E-4340-85A3-A5531E510DB2}">
+      <thm15:themeFamily xmlns:thm15="http://schemas.microsoft.com/office/thememl/2012/main" name="Office Theme" id="{2E142A2C-CD16-42D6-873A-C26D2A0506FA}" vid="{1BDDFF52-6CD6-40A5-AB3C-68EB2F1E4D0A}"/>
+    </a:ext>
+  </a:extLst>
+</a:theme>
 </file>
</xml_diff>